<commit_message>
sync docs/ from travplan@813f942
</commit_message>
<xml_diff>
--- a/slides/research-sensors/research-sensors.pptx
+++ b/slides/research-sensors/research-sensors.pptx
@@ -17,6 +17,8 @@
     <p:sldId id="265" r:id="rId17"/>
     <p:sldId id="266" r:id="rId18"/>
     <p:sldId id="267" r:id="rId19"/>
+    <p:sldId id="268" r:id="rId20"/>
+    <p:sldId id="269" r:id="rId21"/>
   </p:sldIdLst>
   <p:sldSz cx="12192000" cy="6858000" type="screen4x3"/>
   <p:notesSz cx="6858000" cy="9144000"/>
@@ -583,7 +585,7 @@
           <a:lstStyle/>
           <a:p>
             <a:r>
-              <a:t>docs/research-sensors.md · H.4 필요한 연산 성능</a:t>
+              <a:t>docs/research-sensors.md · H.3 예상 가격 (2026-09 기준)</a:t>
             </a:r>
           </a:p>
         </p:txBody>
@@ -653,7 +655,7 @@
           <a:lstStyle/>
           <a:p>
             <a:r>
-              <a:t>docs/research-sensors.md · 탭 '주기·지연'</a:t>
+              <a:t>docs/research-sensors.md · H.3 예상 가격 (2026-09 기준)</a:t>
             </a:r>
           </a:p>
         </p:txBody>
@@ -723,6 +725,146 @@
           <a:lstStyle/>
           <a:p>
             <a:r>
+              <a:t>docs/research-sensors.md · H.4 필요한 연산 성능</a:t>
+            </a:r>
+          </a:p>
+        </p:txBody>
+      </p:sp>
+      <p:sp>
+        <p:nvSpPr>
+          <p:cNvPr id="4" name="Slide Number Placeholder 3"/>
+          <p:cNvSpPr>
+            <a:spLocks noGrp="1"/>
+          </p:cNvSpPr>
+          <p:nvPr>
+            <p:ph type="sldNum" idx="5" sz="quarter"/>
+          </p:nvPr>
+        </p:nvSpPr>
+        <p:spPr/>
+      </p:sp>
+    </p:spTree>
+  </p:cSld>
+  <p:clrMapOvr>
+    <a:masterClrMapping/>
+  </p:clrMapOvr>
+</p:notes>
+</file>
+
+<file path=ppt/notesSlides/notesSlide13.xml><?xml version="1.0" encoding="utf-8"?>
+<p:notes xmlns:a="http://schemas.openxmlformats.org/drawingml/2006/main" xmlns:p="http://schemas.openxmlformats.org/presentationml/2006/main" xmlns:r="http://schemas.openxmlformats.org/officeDocument/2006/relationships">
+  <p:cSld>
+    <p:spTree>
+      <p:nvGrpSpPr>
+        <p:cNvPr id="1" name=""/>
+        <p:cNvGrpSpPr/>
+        <p:nvPr/>
+      </p:nvGrpSpPr>
+      <p:grpSpPr>
+        <a:xfrm>
+          <a:off x="0" y="0"/>
+          <a:ext cx="0" cy="0"/>
+          <a:chOff x="0" y="0"/>
+          <a:chExt cx="0" cy="0"/>
+        </a:xfrm>
+      </p:grpSpPr>
+      <p:sp>
+        <p:nvSpPr>
+          <p:cNvPr id="2" name="Slide Image Placeholder 1"/>
+          <p:cNvSpPr>
+            <a:spLocks noGrp="1"/>
+          </p:cNvSpPr>
+          <p:nvPr>
+            <p:ph type="sldImg" idx="2"/>
+          </p:nvPr>
+        </p:nvSpPr>
+        <p:spPr/>
+      </p:sp>
+      <p:sp>
+        <p:nvSpPr>
+          <p:cNvPr id="3" name="Notes Placeholder 2"/>
+          <p:cNvSpPr>
+            <a:spLocks noGrp="1"/>
+          </p:cNvSpPr>
+          <p:nvPr>
+            <p:ph type="body" idx="3" sz="quarter"/>
+          </p:nvPr>
+        </p:nvSpPr>
+        <p:spPr/>
+        <p:txBody>
+          <a:bodyPr/>
+          <a:lstStyle/>
+          <a:p>
+            <a:r>
+              <a:t>docs/research-sensors.md · 탭 '주기·지연'</a:t>
+            </a:r>
+          </a:p>
+        </p:txBody>
+      </p:sp>
+      <p:sp>
+        <p:nvSpPr>
+          <p:cNvPr id="4" name="Slide Number Placeholder 3"/>
+          <p:cNvSpPr>
+            <a:spLocks noGrp="1"/>
+          </p:cNvSpPr>
+          <p:nvPr>
+            <p:ph type="sldNum" idx="5" sz="quarter"/>
+          </p:nvPr>
+        </p:nvSpPr>
+        <p:spPr/>
+      </p:sp>
+    </p:spTree>
+  </p:cSld>
+  <p:clrMapOvr>
+    <a:masterClrMapping/>
+  </p:clrMapOvr>
+</p:notes>
+</file>
+
+<file path=ppt/notesSlides/notesSlide14.xml><?xml version="1.0" encoding="utf-8"?>
+<p:notes xmlns:a="http://schemas.openxmlformats.org/drawingml/2006/main" xmlns:p="http://schemas.openxmlformats.org/presentationml/2006/main" xmlns:r="http://schemas.openxmlformats.org/officeDocument/2006/relationships">
+  <p:cSld>
+    <p:spTree>
+      <p:nvGrpSpPr>
+        <p:cNvPr id="1" name=""/>
+        <p:cNvGrpSpPr/>
+        <p:nvPr/>
+      </p:nvGrpSpPr>
+      <p:grpSpPr>
+        <a:xfrm>
+          <a:off x="0" y="0"/>
+          <a:ext cx="0" cy="0"/>
+          <a:chOff x="0" y="0"/>
+          <a:chExt cx="0" cy="0"/>
+        </a:xfrm>
+      </p:grpSpPr>
+      <p:sp>
+        <p:nvSpPr>
+          <p:cNvPr id="2" name="Slide Image Placeholder 1"/>
+          <p:cNvSpPr>
+            <a:spLocks noGrp="1"/>
+          </p:cNvSpPr>
+          <p:nvPr>
+            <p:ph type="sldImg" idx="2"/>
+          </p:nvPr>
+        </p:nvSpPr>
+        <p:spPr/>
+      </p:sp>
+      <p:sp>
+        <p:nvSpPr>
+          <p:cNvPr id="3" name="Notes Placeholder 2"/>
+          <p:cNvSpPr>
+            <a:spLocks noGrp="1"/>
+          </p:cNvSpPr>
+          <p:nvPr>
+            <p:ph type="body" idx="3" sz="quarter"/>
+          </p:nvPr>
+        </p:nvSpPr>
+        <p:spPr/>
+        <p:txBody>
+          <a:bodyPr/>
+          <a:lstStyle/>
+          <a:p>
+            <a:r>
               <a:t>docs/research-sensors.md · H.5 센서·지도·계획·제어 주기</a:t>
             </a:r>
           </a:p>
@@ -1143,7 +1285,7 @@
           <a:lstStyle/>
           <a:p>
             <a:r>
-              <a:t>docs/research-sensors.md · 탭 '가격·연산'</a:t>
+              <a:t>docs/research-sensors.md · CODEI — 센서·장착 위치·알고리즘·연산 장치를 비용 가중치로 함께 고른다</a:t>
             </a:r>
           </a:p>
         </p:txBody>
@@ -1213,7 +1355,7 @@
           <a:lstStyle/>
           <a:p>
             <a:r>
-              <a:t>docs/research-sensors.md · H.3 예상 가격 (2026-09 기준)</a:t>
+              <a:t>docs/research-sensors.md · CODEI — 센서·장착 위치·알고리즘·연산 장치를 비용 가중치로 함께 고른다</a:t>
             </a:r>
           </a:p>
         </p:txBody>
@@ -1283,7 +1425,7 @@
           <a:lstStyle/>
           <a:p>
             <a:r>
-              <a:t>docs/research-sensors.md · H.3 예상 가격 (2026-09 기준)</a:t>
+              <a:t>docs/research-sensors.md · 탭 '가격·연산'</a:t>
             </a:r>
           </a:p>
         </p:txBody>
@@ -4453,7 +4595,7 @@
                 <a:ea typeface="Malgun Gothic"/>
                 <a:cs typeface="Malgun Gothic"/>
               </a:rPr>
-              <a:t>travplan 리서치 · 센서 배치 (docs/research-sensors.md)    1 / 12</a:t>
+              <a:t>travplan 리서치 · 센서 배치 (docs/research-sensors.md)    1 / 14</a:t>
             </a:r>
           </a:p>
         </p:txBody>
@@ -4553,7 +4695,18 @@
                 <a:ea typeface="Malgun Gothic"/>
                 <a:cs typeface="Malgun Gothic"/>
               </a:rPr>
-              <a:t>H.4 필요한 연산 성능</a:t>
+              <a:t>H.3 예상 가격 (2026-09 기준)</a:t>
+            </a:r>
+            <a:r>
+              <a:rPr sz="1050" b="0" i="0">
+                <a:solidFill>
+                  <a:srgbClr val="5A6478"/>
+                </a:solidFill>
+                <a:latin typeface="Arial"/>
+                <a:ea typeface="Malgun Gothic"/>
+                <a:cs typeface="Malgun Gothic"/>
+              </a:rPr>
+              <a:t>  1/2</a:t>
             </a:r>
           </a:p>
         </p:txBody>
@@ -4590,7 +4743,1912 @@
                 <a:ea typeface="Malgun Gothic"/>
                 <a:cs typeface="Malgun Gothic"/>
               </a:rPr>
-              <a:t>travplan 리서치 · 센서 배치 (docs/research-sensors.md)    10 / 12</a:t>
+              <a:t>travplan 리서치 · 센서 배치 (docs/research-sensors.md)    10 / 14</a:t>
+            </a:r>
+          </a:p>
+        </p:txBody>
+      </p:sp>
+      <p:sp>
+        <p:nvSpPr>
+          <p:cNvPr id="5" name="TextBox 4"/>
+          <p:cNvSpPr txBox="1"/>
+          <p:nvPr/>
+        </p:nvSpPr>
+        <p:spPr>
+          <a:xfrm>
+            <a:off x="609600" y="1244600"/>
+            <a:ext cx="10972800" cy="216495"/>
+          </a:xfrm>
+          <a:prstGeom prst="rect">
+            <a:avLst/>
+          </a:prstGeom>
+          <a:noFill/>
+        </p:spPr>
+        <p:txBody>
+          <a:bodyPr wrap="square" lIns="0" rIns="0" tIns="0" bIns="0" anchor="t">
+            <a:spAutoFit/>
+            <a:normAutofit/>
+          </a:bodyPr>
+          <a:lstStyle/>
+          <a:p>
+            <a:r>
+              <a:rPr sz="1050" b="1" i="0">
+                <a:solidFill>
+                  <a:srgbClr val="16213A"/>
+                </a:solidFill>
+                <a:latin typeface="Arial"/>
+                <a:ea typeface="Malgun Gothic"/>
+                <a:cs typeface="Malgun Gothic"/>
+              </a:rPr>
+              <a:t>가격은 판매처와 시점에 따라 두 배 가까이 차이 난다. 특히 NVIDIA Jetson은 2026-07에 최대 101% 올랐다.</a:t>
+            </a:r>
+            <a:r>
+              <a:rPr sz="1050" b="0" i="0">
+                <a:solidFill>
+                  <a:srgbClr val="16213A"/>
+                </a:solidFill>
+                <a:latin typeface="Arial"/>
+                <a:ea typeface="Malgun Gothic"/>
+                <a:cs typeface="Malgun Gothic"/>
+              </a:rPr>
+              <a:t> 아래는 공개 가격이고, 양산 수량 가격은 별도 견적이다.</a:t>
+            </a:r>
+          </a:p>
+        </p:txBody>
+      </p:sp>
+      <p:graphicFrame>
+        <p:nvGraphicFramePr>
+          <p:cNvPr id="6" name="Table 5"/>
+          <p:cNvGraphicFramePr>
+            <a:graphicFrameLocks noGrp="1"/>
+          </p:cNvGraphicFramePr>
+          <p:nvPr/>
+        </p:nvGraphicFramePr>
+        <p:xfrm>
+          <a:off x="609600" y="1549995"/>
+          <a:ext cx="10966450" cy="2365056"/>
+        </p:xfrm>
+        <a:graphic>
+          <a:graphicData uri="http://schemas.openxmlformats.org/drawingml/2006/table">
+            <a:tbl>
+              <a:tblPr firstRow="1" bandRow="1">
+                <a:tableStyleId>{5C22544A-7EE6-4342-B048-85BDC9FD1C3A}</a:tableStyleId>
+              </a:tblPr>
+              <a:tblGrid>
+                <a:gridCol w="4859238"/>
+                <a:gridCol w="4035723"/>
+                <a:gridCol w="2071489"/>
+              </a:tblGrid>
+              <a:tr h="197088">
+                <a:tc>
+                  <a:txBody>
+                    <a:bodyPr wrap="square"/>
+                    <a:lstStyle/>
+                    <a:p>
+                      <a:r>
+                        <a:rPr sz="800" b="1" i="0">
+                          <a:solidFill>
+                            <a:srgbClr val="F4F1EA"/>
+                          </a:solidFill>
+                          <a:latin typeface="Arial"/>
+                          <a:ea typeface="Malgun Gothic"/>
+                          <a:cs typeface="Malgun Gothic"/>
+                        </a:rPr>
+                        <a:t>품목</a:t>
+                      </a:r>
+                    </a:p>
+                  </a:txBody>
+                  <a:tcPr marL="63500" marR="63500" marT="12700" marB="12700">
+                    <a:solidFill>
+                      <a:srgbClr val="16213A"/>
+                    </a:solidFill>
+                  </a:tcPr>
+                </a:tc>
+                <a:tc>
+                  <a:txBody>
+                    <a:bodyPr wrap="square"/>
+                    <a:lstStyle/>
+                    <a:p>
+                      <a:r>
+                        <a:rPr sz="800" b="1" i="0">
+                          <a:solidFill>
+                            <a:srgbClr val="F4F1EA"/>
+                          </a:solidFill>
+                          <a:latin typeface="Arial"/>
+                          <a:ea typeface="Malgun Gothic"/>
+                          <a:cs typeface="Malgun Gothic"/>
+                        </a:rPr>
+                        <a:t>가격</a:t>
+                      </a:r>
+                    </a:p>
+                  </a:txBody>
+                  <a:tcPr marL="63500" marR="63500" marT="12700" marB="12700">
+                    <a:solidFill>
+                      <a:srgbClr val="16213A"/>
+                    </a:solidFill>
+                  </a:tcPr>
+                </a:tc>
+                <a:tc>
+                  <a:txBody>
+                    <a:bodyPr wrap="square"/>
+                    <a:lstStyle/>
+                    <a:p>
+                      <a:r>
+                        <a:rPr sz="800" b="1" i="0">
+                          <a:solidFill>
+                            <a:srgbClr val="F4F1EA"/>
+                          </a:solidFill>
+                          <a:latin typeface="Arial"/>
+                          <a:ea typeface="Malgun Gothic"/>
+                          <a:cs typeface="Malgun Gothic"/>
+                        </a:rPr>
+                        <a:t>출처</a:t>
+                      </a:r>
+                    </a:p>
+                  </a:txBody>
+                  <a:tcPr marL="63500" marR="63500" marT="12700" marB="12700">
+                    <a:solidFill>
+                      <a:srgbClr val="16213A"/>
+                    </a:solidFill>
+                  </a:tcPr>
+                </a:tc>
+              </a:tr>
+              <a:tr h="197088">
+                <a:tc>
+                  <a:txBody>
+                    <a:bodyPr wrap="square"/>
+                    <a:lstStyle/>
+                    <a:p>
+                      <a:r>
+                        <a:rPr sz="800" b="0" i="0">
+                          <a:solidFill>
+                            <a:srgbClr val="16213A"/>
+                          </a:solidFill>
+                          <a:latin typeface="Arial"/>
+                          <a:ea typeface="Malgun Gothic"/>
+                          <a:cs typeface="Malgun Gothic"/>
+                        </a:rPr>
+                        <a:t>Livox Mid-360(360° × 59°, 10 Hz, 초당 20만 점)</a:t>
+                      </a:r>
+                    </a:p>
+                  </a:txBody>
+                  <a:tcPr marL="63500" marR="63500" marT="12700" marB="12700">
+                    <a:solidFill>
+                      <a:srgbClr val="FFFDF8"/>
+                    </a:solidFill>
+                  </a:tcPr>
+                </a:tc>
+                <a:tc>
+                  <a:txBody>
+                    <a:bodyPr wrap="square"/>
+                    <a:lstStyle/>
+                    <a:p>
+                      <a:r>
+                        <a:rPr sz="800" b="0" i="0">
+                          <a:solidFill>
+                            <a:srgbClr val="16213A"/>
+                          </a:solidFill>
+                          <a:latin typeface="Arial"/>
+                          <a:ea typeface="Malgun Gothic"/>
+                          <a:cs typeface="Malgun Gothic"/>
+                        </a:rPr>
+                        <a:t>소매 약 480–1,350달러(판매처별)</a:t>
+                      </a:r>
+                    </a:p>
+                  </a:txBody>
+                  <a:tcPr marL="63500" marR="63500" marT="12700" marB="12700">
+                    <a:solidFill>
+                      <a:srgbClr val="FFFDF8"/>
+                    </a:solidFill>
+                  </a:tcPr>
+                </a:tc>
+                <a:tc>
+                  <a:txBody>
+                    <a:bodyPr wrap="square"/>
+                    <a:lstStyle/>
+                    <a:p>
+                      <a:r>
+                        <a:rPr sz="800" b="0" i="0">
+                          <a:solidFill>
+                            <a:srgbClr val="1D4ED8"/>
+                          </a:solidFill>
+                          <a:latin typeface="Arial"/>
+                          <a:ea typeface="Malgun Gothic"/>
+                          <a:cs typeface="Malgun Gothic"/>
+                          <a:hlinkClick r:id="rId3"/>
+                        </a:rPr>
+                        <a:t>Livox 사양</a:t>
+                      </a:r>
+                      <a:r>
+                        <a:rPr sz="800" b="0" i="0">
+                          <a:solidFill>
+                            <a:srgbClr val="16213A"/>
+                          </a:solidFill>
+                          <a:latin typeface="Arial"/>
+                          <a:ea typeface="Malgun Gothic"/>
+                          <a:cs typeface="Malgun Gothic"/>
+                        </a:rPr>
+                        <a:t>, </a:t>
+                      </a:r>
+                      <a:r>
+                        <a:rPr sz="800" b="0" i="0">
+                          <a:solidFill>
+                            <a:srgbClr val="1D4ED8"/>
+                          </a:solidFill>
+                          <a:latin typeface="Arial"/>
+                          <a:ea typeface="Malgun Gothic"/>
+                          <a:cs typeface="Malgun Gothic"/>
+                          <a:hlinkClick r:id="rId4"/>
+                        </a:rPr>
+                        <a:t>Vertex</a:t>
+                      </a:r>
+                    </a:p>
+                  </a:txBody>
+                  <a:tcPr marL="63500" marR="63500" marT="12700" marB="12700">
+                    <a:solidFill>
+                      <a:srgbClr val="FFFDF8"/>
+                    </a:solidFill>
+                  </a:tcPr>
+                </a:tc>
+              </a:tr>
+              <a:tr h="197088">
+                <a:tc>
+                  <a:txBody>
+                    <a:bodyPr wrap="square"/>
+                    <a:lstStyle/>
+                    <a:p>
+                      <a:r>
+                        <a:rPr sz="800" b="0" i="0">
+                          <a:solidFill>
+                            <a:srgbClr val="16213A"/>
+                          </a:solidFill>
+                          <a:latin typeface="Arial"/>
+                          <a:ea typeface="Malgun Gothic"/>
+                          <a:cs typeface="Malgun Gothic"/>
+                        </a:rPr>
+                        <a:t>Unitree 4D LiDAR L2(360° × 96°, 30 m)</a:t>
+                      </a:r>
+                    </a:p>
+                  </a:txBody>
+                  <a:tcPr marL="63500" marR="63500" marT="12700" marB="12700">
+                    <a:solidFill>
+                      <a:srgbClr val="F3F0E8"/>
+                    </a:solidFill>
+                  </a:tcPr>
+                </a:tc>
+                <a:tc>
+                  <a:txBody>
+                    <a:bodyPr wrap="square"/>
+                    <a:lstStyle/>
+                    <a:p>
+                      <a:r>
+                        <a:rPr sz="800" b="0" i="0">
+                          <a:solidFill>
+                            <a:srgbClr val="16213A"/>
+                          </a:solidFill>
+                          <a:latin typeface="Arial"/>
+                          <a:ea typeface="Malgun Gothic"/>
+                          <a:cs typeface="Malgun Gothic"/>
+                        </a:rPr>
+                        <a:t>419달러</a:t>
+                      </a:r>
+                    </a:p>
+                  </a:txBody>
+                  <a:tcPr marL="63500" marR="63500" marT="12700" marB="12700">
+                    <a:solidFill>
+                      <a:srgbClr val="F3F0E8"/>
+                    </a:solidFill>
+                  </a:tcPr>
+                </a:tc>
+                <a:tc>
+                  <a:txBody>
+                    <a:bodyPr wrap="square"/>
+                    <a:lstStyle/>
+                    <a:p>
+                      <a:r>
+                        <a:rPr sz="800" b="0" i="0">
+                          <a:solidFill>
+                            <a:srgbClr val="1D4ED8"/>
+                          </a:solidFill>
+                          <a:latin typeface="Arial"/>
+                          <a:ea typeface="Malgun Gothic"/>
+                          <a:cs typeface="Malgun Gothic"/>
+                          <a:hlinkClick r:id="rId5"/>
+                        </a:rPr>
+                        <a:t>Unitree</a:t>
+                      </a:r>
+                    </a:p>
+                  </a:txBody>
+                  <a:tcPr marL="63500" marR="63500" marT="12700" marB="12700">
+                    <a:solidFill>
+                      <a:srgbClr val="F3F0E8"/>
+                    </a:solidFill>
+                  </a:tcPr>
+                </a:tc>
+              </a:tr>
+              <a:tr h="197088">
+                <a:tc>
+                  <a:txBody>
+                    <a:bodyPr wrap="square"/>
+                    <a:lstStyle/>
+                    <a:p>
+                      <a:r>
+                        <a:rPr sz="800" b="0" i="0">
+                          <a:solidFill>
+                            <a:srgbClr val="16213A"/>
+                          </a:solidFill>
+                          <a:latin typeface="Arial"/>
+                          <a:ea typeface="Malgun Gothic"/>
+                          <a:cs typeface="Malgun Gothic"/>
+                        </a:rPr>
+                        <a:t>Ouster OS1-32</a:t>
+                      </a:r>
+                    </a:p>
+                  </a:txBody>
+                  <a:tcPr marL="63500" marR="63500" marT="12700" marB="12700">
+                    <a:solidFill>
+                      <a:srgbClr val="FFFDF8"/>
+                    </a:solidFill>
+                  </a:tcPr>
+                </a:tc>
+                <a:tc>
+                  <a:txBody>
+                    <a:bodyPr wrap="square"/>
+                    <a:lstStyle/>
+                    <a:p>
+                      <a:r>
+                        <a:rPr sz="800" b="0" i="0">
+                          <a:solidFill>
+                            <a:srgbClr val="16213A"/>
+                          </a:solidFill>
+                          <a:latin typeface="Arial"/>
+                          <a:ea typeface="Malgun Gothic"/>
+                          <a:cs typeface="Malgun Gothic"/>
+                        </a:rPr>
+                        <a:t>6,000달러부터(출시 당시)</a:t>
+                      </a:r>
+                    </a:p>
+                  </a:txBody>
+                  <a:tcPr marL="63500" marR="63500" marT="12700" marB="12700">
+                    <a:solidFill>
+                      <a:srgbClr val="FFFDF8"/>
+                    </a:solidFill>
+                  </a:tcPr>
+                </a:tc>
+                <a:tc>
+                  <a:txBody>
+                    <a:bodyPr wrap="square"/>
+                    <a:lstStyle/>
+                    <a:p>
+                      <a:r>
+                        <a:rPr sz="800" b="0" i="0">
+                          <a:solidFill>
+                            <a:srgbClr val="1D4ED8"/>
+                          </a:solidFill>
+                          <a:latin typeface="Arial"/>
+                          <a:ea typeface="Malgun Gothic"/>
+                          <a:cs typeface="Malgun Gothic"/>
+                          <a:hlinkClick r:id="rId6"/>
+                        </a:rPr>
+                        <a:t>Ouster</a:t>
+                      </a:r>
+                    </a:p>
+                  </a:txBody>
+                  <a:tcPr marL="63500" marR="63500" marT="12700" marB="12700">
+                    <a:solidFill>
+                      <a:srgbClr val="FFFDF8"/>
+                    </a:solidFill>
+                  </a:tcPr>
+                </a:tc>
+              </a:tr>
+              <a:tr h="197088">
+                <a:tc>
+                  <a:txBody>
+                    <a:bodyPr wrap="square"/>
+                    <a:lstStyle/>
+                    <a:p>
+                      <a:r>
+                        <a:rPr sz="800" b="0" i="0">
+                          <a:solidFill>
+                            <a:srgbClr val="16213A"/>
+                          </a:solidFill>
+                          <a:latin typeface="Arial"/>
+                          <a:ea typeface="Malgun Gothic"/>
+                          <a:cs typeface="Malgun Gothic"/>
+                        </a:rPr>
+                        <a:t>RoboSense Airy, Hesai JT128</a:t>
+                      </a:r>
+                    </a:p>
+                  </a:txBody>
+                  <a:tcPr marL="63500" marR="63500" marT="12700" marB="12700">
+                    <a:solidFill>
+                      <a:srgbClr val="F3F0E8"/>
+                    </a:solidFill>
+                  </a:tcPr>
+                </a:tc>
+                <a:tc>
+                  <a:txBody>
+                    <a:bodyPr wrap="square"/>
+                    <a:lstStyle/>
+                    <a:p>
+                      <a:r>
+                        <a:rPr sz="800" b="0" i="0">
+                          <a:solidFill>
+                            <a:srgbClr val="16213A"/>
+                          </a:solidFill>
+                          <a:latin typeface="Arial"/>
+                          <a:ea typeface="Malgun Gothic"/>
+                          <a:cs typeface="Malgun Gothic"/>
+                        </a:rPr>
+                        <a:t>견적</a:t>
+                      </a:r>
+                    </a:p>
+                  </a:txBody>
+                  <a:tcPr marL="63500" marR="63500" marT="12700" marB="12700">
+                    <a:solidFill>
+                      <a:srgbClr val="F3F0E8"/>
+                    </a:solidFill>
+                  </a:tcPr>
+                </a:tc>
+                <a:tc>
+                  <a:txBody>
+                    <a:bodyPr wrap="square"/>
+                    <a:lstStyle/>
+                    <a:p>
+                      <a:r>
+                        <a:rPr sz="800" b="0" i="0">
+                          <a:solidFill>
+                            <a:srgbClr val="1D4ED8"/>
+                          </a:solidFill>
+                          <a:latin typeface="Arial"/>
+                          <a:ea typeface="Malgun Gothic"/>
+                          <a:cs typeface="Malgun Gothic"/>
+                          <a:hlinkClick r:id="rId7"/>
+                        </a:rPr>
+                        <a:t>RoboSense</a:t>
+                      </a:r>
+                      <a:r>
+                        <a:rPr sz="800" b="0" i="0">
+                          <a:solidFill>
+                            <a:srgbClr val="16213A"/>
+                          </a:solidFill>
+                          <a:latin typeface="Arial"/>
+                          <a:ea typeface="Malgun Gothic"/>
+                          <a:cs typeface="Malgun Gothic"/>
+                        </a:rPr>
+                        <a:t>, </a:t>
+                      </a:r>
+                      <a:r>
+                        <a:rPr sz="800" b="0" i="0">
+                          <a:solidFill>
+                            <a:srgbClr val="1D4ED8"/>
+                          </a:solidFill>
+                          <a:latin typeface="Arial"/>
+                          <a:ea typeface="Malgun Gothic"/>
+                          <a:cs typeface="Malgun Gothic"/>
+                          <a:hlinkClick r:id="rId8"/>
+                        </a:rPr>
+                        <a:t>Hesai</a:t>
+                      </a:r>
+                    </a:p>
+                  </a:txBody>
+                  <a:tcPr marL="63500" marR="63500" marT="12700" marB="12700">
+                    <a:solidFill>
+                      <a:srgbClr val="F3F0E8"/>
+                    </a:solidFill>
+                  </a:tcPr>
+                </a:tc>
+              </a:tr>
+              <a:tr h="197088">
+                <a:tc>
+                  <a:txBody>
+                    <a:bodyPr wrap="square"/>
+                    <a:lstStyle/>
+                    <a:p>
+                      <a:r>
+                        <a:rPr sz="800" b="0" i="0">
+                          <a:solidFill>
+                            <a:srgbClr val="16213A"/>
+                          </a:solidFill>
+                          <a:latin typeface="Arial"/>
+                          <a:ea typeface="Malgun Gothic"/>
+                          <a:cs typeface="Malgun Gothic"/>
+                        </a:rPr>
+                        <a:t>Stereolabs ZED X Mini(GMSL2 스테레오)</a:t>
+                      </a:r>
+                    </a:p>
+                  </a:txBody>
+                  <a:tcPr marL="63500" marR="63500" marT="12700" marB="12700">
+                    <a:solidFill>
+                      <a:srgbClr val="FFFDF8"/>
+                    </a:solidFill>
+                  </a:tcPr>
+                </a:tc>
+                <a:tc>
+                  <a:txBody>
+                    <a:bodyPr wrap="square"/>
+                    <a:lstStyle/>
+                    <a:p>
+                      <a:r>
+                        <a:rPr sz="800" b="0" i="0">
+                          <a:solidFill>
+                            <a:srgbClr val="16213A"/>
+                          </a:solidFill>
+                          <a:latin typeface="Arial"/>
+                          <a:ea typeface="Malgun Gothic"/>
+                          <a:cs typeface="Malgun Gothic"/>
+                        </a:rPr>
+                        <a:t>549달러</a:t>
+                      </a:r>
+                    </a:p>
+                  </a:txBody>
+                  <a:tcPr marL="63500" marR="63500" marT="12700" marB="12700">
+                    <a:solidFill>
+                      <a:srgbClr val="FFFDF8"/>
+                    </a:solidFill>
+                  </a:tcPr>
+                </a:tc>
+                <a:tc>
+                  <a:txBody>
+                    <a:bodyPr wrap="square"/>
+                    <a:lstStyle/>
+                    <a:p>
+                      <a:r>
+                        <a:rPr sz="800" b="0" i="0">
+                          <a:solidFill>
+                            <a:srgbClr val="1D4ED8"/>
+                          </a:solidFill>
+                          <a:latin typeface="Arial"/>
+                          <a:ea typeface="Malgun Gothic"/>
+                          <a:cs typeface="Malgun Gothic"/>
+                          <a:hlinkClick r:id="rId9"/>
+                        </a:rPr>
+                        <a:t>Stereolabs</a:t>
+                      </a:r>
+                    </a:p>
+                  </a:txBody>
+                  <a:tcPr marL="63500" marR="63500" marT="12700" marB="12700">
+                    <a:solidFill>
+                      <a:srgbClr val="FFFDF8"/>
+                    </a:solidFill>
+                  </a:tcPr>
+                </a:tc>
+              </a:tr>
+              <a:tr h="197088">
+                <a:tc>
+                  <a:txBody>
+                    <a:bodyPr wrap="square"/>
+                    <a:lstStyle/>
+                    <a:p>
+                      <a:r>
+                        <a:rPr sz="800" b="0" i="0">
+                          <a:solidFill>
+                            <a:srgbClr val="16213A"/>
+                          </a:solidFill>
+                          <a:latin typeface="Arial"/>
+                          <a:ea typeface="Malgun Gothic"/>
+                          <a:cs typeface="Malgun Gothic"/>
+                        </a:rPr>
+                        <a:t>Stereolabs ZED X</a:t>
+                      </a:r>
+                    </a:p>
+                  </a:txBody>
+                  <a:tcPr marL="63500" marR="63500" marT="12700" marB="12700">
+                    <a:solidFill>
+                      <a:srgbClr val="F3F0E8"/>
+                    </a:solidFill>
+                  </a:tcPr>
+                </a:tc>
+                <a:tc>
+                  <a:txBody>
+                    <a:bodyPr wrap="square"/>
+                    <a:lstStyle/>
+                    <a:p>
+                      <a:r>
+                        <a:rPr sz="800" b="0" i="0">
+                          <a:solidFill>
+                            <a:srgbClr val="16213A"/>
+                          </a:solidFill>
+                          <a:latin typeface="Arial"/>
+                          <a:ea typeface="Malgun Gothic"/>
+                          <a:cs typeface="Malgun Gothic"/>
+                        </a:rPr>
+                        <a:t>599달러부터</a:t>
+                      </a:r>
+                    </a:p>
+                  </a:txBody>
+                  <a:tcPr marL="63500" marR="63500" marT="12700" marB="12700">
+                    <a:solidFill>
+                      <a:srgbClr val="F3F0E8"/>
+                    </a:solidFill>
+                  </a:tcPr>
+                </a:tc>
+                <a:tc>
+                  <a:txBody>
+                    <a:bodyPr wrap="square"/>
+                    <a:lstStyle/>
+                    <a:p>
+                      <a:r>
+                        <a:rPr sz="800" b="0" i="0">
+                          <a:solidFill>
+                            <a:srgbClr val="1D4ED8"/>
+                          </a:solidFill>
+                          <a:latin typeface="Arial"/>
+                          <a:ea typeface="Malgun Gothic"/>
+                          <a:cs typeface="Malgun Gothic"/>
+                          <a:hlinkClick r:id="rId10"/>
+                        </a:rPr>
+                        <a:t>Stereolabs</a:t>
+                      </a:r>
+                    </a:p>
+                  </a:txBody>
+                  <a:tcPr marL="63500" marR="63500" marT="12700" marB="12700">
+                    <a:solidFill>
+                      <a:srgbClr val="F3F0E8"/>
+                    </a:solidFill>
+                  </a:tcPr>
+                </a:tc>
+              </a:tr>
+              <a:tr h="197088">
+                <a:tc>
+                  <a:txBody>
+                    <a:bodyPr wrap="square"/>
+                    <a:lstStyle/>
+                    <a:p>
+                      <a:r>
+                        <a:rPr sz="800" b="0" i="0">
+                          <a:solidFill>
+                            <a:srgbClr val="16213A"/>
+                          </a:solidFill>
+                          <a:latin typeface="Arial"/>
+                          <a:ea typeface="Malgun Gothic"/>
+                          <a:cs typeface="Malgun Gothic"/>
+                        </a:rPr>
+                        <a:t>GMSL2 차량용 카메라(IMX490, 120 dB HDR 등)</a:t>
+                      </a:r>
+                    </a:p>
+                  </a:txBody>
+                  <a:tcPr marL="63500" marR="63500" marT="12700" marB="12700">
+                    <a:solidFill>
+                      <a:srgbClr val="FFFDF8"/>
+                    </a:solidFill>
+                  </a:tcPr>
+                </a:tc>
+                <a:tc>
+                  <a:txBody>
+                    <a:bodyPr wrap="square"/>
+                    <a:lstStyle/>
+                    <a:p>
+                      <a:r>
+                        <a:rPr sz="800" b="0" i="0">
+                          <a:solidFill>
+                            <a:srgbClr val="16213A"/>
+                          </a:solidFill>
+                          <a:latin typeface="Arial"/>
+                          <a:ea typeface="Malgun Gothic"/>
+                          <a:cs typeface="Malgun Gothic"/>
+                        </a:rPr>
+                        <a:t>견적</a:t>
+                      </a:r>
+                    </a:p>
+                  </a:txBody>
+                  <a:tcPr marL="63500" marR="63500" marT="12700" marB="12700">
+                    <a:solidFill>
+                      <a:srgbClr val="FFFDF8"/>
+                    </a:solidFill>
+                  </a:tcPr>
+                </a:tc>
+                <a:tc>
+                  <a:txBody>
+                    <a:bodyPr wrap="square"/>
+                    <a:lstStyle/>
+                    <a:p>
+                      <a:r>
+                        <a:rPr sz="800" b="0" i="0">
+                          <a:solidFill>
+                            <a:srgbClr val="1D4ED8"/>
+                          </a:solidFill>
+                          <a:latin typeface="Arial"/>
+                          <a:ea typeface="Malgun Gothic"/>
+                          <a:cs typeface="Malgun Gothic"/>
+                          <a:hlinkClick r:id="rId11"/>
+                        </a:rPr>
+                        <a:t>Leopard Imaging</a:t>
+                      </a:r>
+                    </a:p>
+                  </a:txBody>
+                  <a:tcPr marL="63500" marR="63500" marT="12700" marB="12700">
+                    <a:solidFill>
+                      <a:srgbClr val="FFFDF8"/>
+                    </a:solidFill>
+                  </a:tcPr>
+                </a:tc>
+              </a:tr>
+              <a:tr h="197088">
+                <a:tc>
+                  <a:txBody>
+                    <a:bodyPr wrap="square"/>
+                    <a:lstStyle/>
+                    <a:p>
+                      <a:r>
+                        <a:rPr sz="800" b="0" i="0">
+                          <a:solidFill>
+                            <a:srgbClr val="16213A"/>
+                          </a:solidFill>
+                          <a:latin typeface="Arial"/>
+                          <a:ea typeface="Malgun Gothic"/>
+                          <a:cs typeface="Malgun Gothic"/>
+                        </a:rPr>
+                        <a:t>Jetson AGX Orin 64GB 모듈 / 32GB 모듈</a:t>
+                      </a:r>
+                    </a:p>
+                  </a:txBody>
+                  <a:tcPr marL="63500" marR="63500" marT="12700" marB="12700">
+                    <a:solidFill>
+                      <a:srgbClr val="F3F0E8"/>
+                    </a:solidFill>
+                  </a:tcPr>
+                </a:tc>
+                <a:tc>
+                  <a:txBody>
+                    <a:bodyPr wrap="square"/>
+                    <a:lstStyle/>
+                    <a:p>
+                      <a:r>
+                        <a:rPr sz="800" b="0" i="0">
+                          <a:solidFill>
+                            <a:srgbClr val="16213A"/>
+                          </a:solidFill>
+                          <a:latin typeface="Arial"/>
+                          <a:ea typeface="Malgun Gothic"/>
+                          <a:cs typeface="Malgun Gothic"/>
+                        </a:rPr>
+                        <a:t>2,999 / 1,799달러(인상 전 1,599 / 899)</a:t>
+                      </a:r>
+                    </a:p>
+                  </a:txBody>
+                  <a:tcPr marL="63500" marR="63500" marT="12700" marB="12700">
+                    <a:solidFill>
+                      <a:srgbClr val="F3F0E8"/>
+                    </a:solidFill>
+                  </a:tcPr>
+                </a:tc>
+                <a:tc>
+                  <a:txBody>
+                    <a:bodyPr wrap="square"/>
+                    <a:lstStyle/>
+                    <a:p>
+                      <a:r>
+                        <a:rPr sz="800" b="0" i="0">
+                          <a:solidFill>
+                            <a:srgbClr val="1D4ED8"/>
+                          </a:solidFill>
+                          <a:latin typeface="Arial"/>
+                          <a:ea typeface="Malgun Gothic"/>
+                          <a:cs typeface="Malgun Gothic"/>
+                          <a:hlinkClick r:id="rId12"/>
+                        </a:rPr>
+                        <a:t>CNX Software</a:t>
+                      </a:r>
+                    </a:p>
+                  </a:txBody>
+                  <a:tcPr marL="63500" marR="63500" marT="12700" marB="12700">
+                    <a:solidFill>
+                      <a:srgbClr val="F3F0E8"/>
+                    </a:solidFill>
+                  </a:tcPr>
+                </a:tc>
+              </a:tr>
+              <a:tr h="197088">
+                <a:tc>
+                  <a:txBody>
+                    <a:bodyPr wrap="square"/>
+                    <a:lstStyle/>
+                    <a:p>
+                      <a:r>
+                        <a:rPr sz="800" b="0" i="0">
+                          <a:solidFill>
+                            <a:srgbClr val="16213A"/>
+                          </a:solidFill>
+                          <a:latin typeface="Arial"/>
+                          <a:ea typeface="Malgun Gothic"/>
+                          <a:cs typeface="Malgun Gothic"/>
+                        </a:rPr>
+                        <a:t>Jetson AGX Orin 개발 키트</a:t>
+                      </a:r>
+                    </a:p>
+                  </a:txBody>
+                  <a:tcPr marL="63500" marR="63500" marT="12700" marB="12700">
+                    <a:solidFill>
+                      <a:srgbClr val="FFFDF8"/>
+                    </a:solidFill>
+                  </a:tcPr>
+                </a:tc>
+                <a:tc>
+                  <a:txBody>
+                    <a:bodyPr wrap="square"/>
+                    <a:lstStyle/>
+                    <a:p>
+                      <a:r>
+                        <a:rPr sz="800" b="0" i="0">
+                          <a:solidFill>
+                            <a:srgbClr val="16213A"/>
+                          </a:solidFill>
+                          <a:latin typeface="Arial"/>
+                          <a:ea typeface="Malgun Gothic"/>
+                          <a:cs typeface="Malgun Gothic"/>
+                        </a:rPr>
+                        <a:t>3,499달러(인상 전 1,999)</a:t>
+                      </a:r>
+                    </a:p>
+                  </a:txBody>
+                  <a:tcPr marL="63500" marR="63500" marT="12700" marB="12700">
+                    <a:solidFill>
+                      <a:srgbClr val="FFFDF8"/>
+                    </a:solidFill>
+                  </a:tcPr>
+                </a:tc>
+                <a:tc>
+                  <a:txBody>
+                    <a:bodyPr wrap="square"/>
+                    <a:lstStyle/>
+                    <a:p>
+                      <a:r>
+                        <a:rPr sz="800" b="0" i="0">
+                          <a:solidFill>
+                            <a:srgbClr val="16213A"/>
+                          </a:solidFill>
+                          <a:latin typeface="Arial"/>
+                          <a:ea typeface="Malgun Gothic"/>
+                          <a:cs typeface="Malgun Gothic"/>
+                        </a:rPr>
+                        <a:t>같음</a:t>
+                      </a:r>
+                    </a:p>
+                  </a:txBody>
+                  <a:tcPr marL="63500" marR="63500" marT="12700" marB="12700">
+                    <a:solidFill>
+                      <a:srgbClr val="FFFDF8"/>
+                    </a:solidFill>
+                  </a:tcPr>
+                </a:tc>
+              </a:tr>
+              <a:tr h="197088">
+                <a:tc>
+                  <a:txBody>
+                    <a:bodyPr wrap="square"/>
+                    <a:lstStyle/>
+                    <a:p>
+                      <a:r>
+                        <a:rPr sz="800" b="0" i="0">
+                          <a:solidFill>
+                            <a:srgbClr val="16213A"/>
+                          </a:solidFill>
+                          <a:latin typeface="Arial"/>
+                          <a:ea typeface="Malgun Gothic"/>
+                          <a:cs typeface="Malgun Gothic"/>
+                        </a:rPr>
+                        <a:t>Jetson Orin NX 16GB 모듈</a:t>
+                      </a:r>
+                    </a:p>
+                  </a:txBody>
+                  <a:tcPr marL="63500" marR="63500" marT="12700" marB="12700">
+                    <a:solidFill>
+                      <a:srgbClr val="F3F0E8"/>
+                    </a:solidFill>
+                  </a:tcPr>
+                </a:tc>
+                <a:tc>
+                  <a:txBody>
+                    <a:bodyPr wrap="square"/>
+                    <a:lstStyle/>
+                    <a:p>
+                      <a:r>
+                        <a:rPr sz="800" b="0" i="0">
+                          <a:solidFill>
+                            <a:srgbClr val="16213A"/>
+                          </a:solidFill>
+                          <a:latin typeface="Arial"/>
+                          <a:ea typeface="Malgun Gothic"/>
+                          <a:cs typeface="Malgun Gothic"/>
+                        </a:rPr>
+                        <a:t>999달러(인상 전 599)</a:t>
+                      </a:r>
+                    </a:p>
+                  </a:txBody>
+                  <a:tcPr marL="63500" marR="63500" marT="12700" marB="12700">
+                    <a:solidFill>
+                      <a:srgbClr val="F3F0E8"/>
+                    </a:solidFill>
+                  </a:tcPr>
+                </a:tc>
+                <a:tc>
+                  <a:txBody>
+                    <a:bodyPr wrap="square"/>
+                    <a:lstStyle/>
+                    <a:p>
+                      <a:r>
+                        <a:rPr sz="800" b="0" i="0">
+                          <a:solidFill>
+                            <a:srgbClr val="16213A"/>
+                          </a:solidFill>
+                          <a:latin typeface="Arial"/>
+                          <a:ea typeface="Malgun Gothic"/>
+                          <a:cs typeface="Malgun Gothic"/>
+                        </a:rPr>
+                        <a:t>같음</a:t>
+                      </a:r>
+                    </a:p>
+                  </a:txBody>
+                  <a:tcPr marL="63500" marR="63500" marT="12700" marB="12700">
+                    <a:solidFill>
+                      <a:srgbClr val="F3F0E8"/>
+                    </a:solidFill>
+                  </a:tcPr>
+                </a:tc>
+              </a:tr>
+              <a:tr h="197088">
+                <a:tc>
+                  <a:txBody>
+                    <a:bodyPr wrap="square"/>
+                    <a:lstStyle/>
+                    <a:p>
+                      <a:r>
+                        <a:rPr sz="800" b="0" i="0">
+                          <a:solidFill>
+                            <a:srgbClr val="16213A"/>
+                          </a:solidFill>
+                          <a:latin typeface="Arial"/>
+                          <a:ea typeface="Malgun Gothic"/>
+                          <a:cs typeface="Malgun Gothic"/>
+                        </a:rPr>
+                        <a:t>Jetson T4000 / T5000(Thor) 모듈</a:t>
+                      </a:r>
+                    </a:p>
+                  </a:txBody>
+                  <a:tcPr marL="63500" marR="63500" marT="12700" marB="12700">
+                    <a:solidFill>
+                      <a:srgbClr val="FFFDF8"/>
+                    </a:solidFill>
+                  </a:tcPr>
+                </a:tc>
+                <a:tc>
+                  <a:txBody>
+                    <a:bodyPr wrap="square"/>
+                    <a:lstStyle/>
+                    <a:p>
+                      <a:r>
+                        <a:rPr sz="800" b="0" i="0">
+                          <a:solidFill>
+                            <a:srgbClr val="16213A"/>
+                          </a:solidFill>
+                          <a:latin typeface="Arial"/>
+                          <a:ea typeface="Malgun Gothic"/>
+                          <a:cs typeface="Malgun Gothic"/>
+                        </a:rPr>
+                        <a:t>2,999 / 4,999달러</a:t>
+                      </a:r>
+                    </a:p>
+                  </a:txBody>
+                  <a:tcPr marL="63500" marR="63500" marT="12700" marB="12700">
+                    <a:solidFill>
+                      <a:srgbClr val="FFFDF8"/>
+                    </a:solidFill>
+                  </a:tcPr>
+                </a:tc>
+                <a:tc>
+                  <a:txBody>
+                    <a:bodyPr wrap="square"/>
+                    <a:lstStyle/>
+                    <a:p>
+                      <a:r>
+                        <a:rPr sz="800" b="0" i="0">
+                          <a:solidFill>
+                            <a:srgbClr val="16213A"/>
+                          </a:solidFill>
+                          <a:latin typeface="Arial"/>
+                          <a:ea typeface="Malgun Gothic"/>
+                          <a:cs typeface="Malgun Gothic"/>
+                        </a:rPr>
+                        <a:t>같음</a:t>
+                      </a:r>
+                    </a:p>
+                  </a:txBody>
+                  <a:tcPr marL="63500" marR="63500" marT="12700" marB="12700">
+                    <a:solidFill>
+                      <a:srgbClr val="FFFDF8"/>
+                    </a:solidFill>
+                  </a:tcPr>
+                </a:tc>
+              </a:tr>
+            </a:tbl>
+          </a:graphicData>
+        </a:graphic>
+      </p:graphicFrame>
+      <p:sp>
+        <p:nvSpPr>
+          <p:cNvPr id="7" name="TextBox 6"/>
+          <p:cNvSpPr txBox="1"/>
+          <p:nvPr/>
+        </p:nvSpPr>
+        <p:spPr>
+          <a:xfrm>
+            <a:off x="609600" y="4601567"/>
+            <a:ext cx="10972800" cy="216495"/>
+          </a:xfrm>
+          <a:prstGeom prst="rect">
+            <a:avLst/>
+          </a:prstGeom>
+          <a:noFill/>
+        </p:spPr>
+        <p:txBody>
+          <a:bodyPr wrap="square" lIns="0" rIns="0" tIns="0" bIns="0" anchor="t">
+            <a:spAutoFit/>
+            <a:normAutofit/>
+          </a:bodyPr>
+          <a:lstStyle/>
+          <a:p>
+            <a:r>
+              <a:rPr sz="1050" b="1" i="0">
+                <a:solidFill>
+                  <a:srgbClr val="16213A"/>
+                </a:solidFill>
+                <a:latin typeface="Arial"/>
+                <a:ea typeface="Malgun Gothic"/>
+                <a:cs typeface="Malgun Gothic"/>
+              </a:rPr>
+              <a:t>배치별 센서 + 연산 예산(대략).</a:t>
+            </a:r>
+            <a:r>
+              <a:rPr sz="1050" b="0" i="0">
+                <a:solidFill>
+                  <a:srgbClr val="16213A"/>
+                </a:solidFill>
+                <a:latin typeface="Arial"/>
+                <a:ea typeface="Malgun Gothic"/>
+                <a:cs typeface="Malgun Gothic"/>
+              </a:rPr>
+              <a:t> 카메라 한 대를 200–600달러로 보면 다음과 같다.</a:t>
+            </a:r>
+          </a:p>
+        </p:txBody>
+      </p:sp>
+      <p:graphicFrame>
+        <p:nvGraphicFramePr>
+          <p:cNvPr id="8" name="Table 7"/>
+          <p:cNvGraphicFramePr>
+            <a:graphicFrameLocks noGrp="1"/>
+          </p:cNvGraphicFramePr>
+          <p:nvPr/>
+        </p:nvGraphicFramePr>
+        <p:xfrm>
+          <a:off x="609600" y="4906962"/>
+          <a:ext cx="10966450" cy="985440"/>
+        </p:xfrm>
+        <a:graphic>
+          <a:graphicData uri="http://schemas.openxmlformats.org/drawingml/2006/table">
+            <a:tbl>
+              <a:tblPr firstRow="1" bandRow="1">
+                <a:tableStyleId>{5C22544A-7EE6-4342-B048-85BDC9FD1C3A}</a:tableStyleId>
+              </a:tblPr>
+              <a:tblGrid>
+                <a:gridCol w="3432373"/>
+                <a:gridCol w="1907977"/>
+                <a:gridCol w="3606800"/>
+                <a:gridCol w="2019300"/>
+              </a:tblGrid>
+              <a:tr h="197088">
+                <a:tc>
+                  <a:txBody>
+                    <a:bodyPr wrap="square"/>
+                    <a:lstStyle/>
+                    <a:p>
+                      <a:r>
+                        <a:rPr sz="800" b="1" i="0">
+                          <a:solidFill>
+                            <a:srgbClr val="F4F1EA"/>
+                          </a:solidFill>
+                          <a:latin typeface="Arial"/>
+                          <a:ea typeface="Malgun Gothic"/>
+                          <a:cs typeface="Malgun Gothic"/>
+                        </a:rPr>
+                        <a:t>배치</a:t>
+                      </a:r>
+                    </a:p>
+                  </a:txBody>
+                  <a:tcPr marL="63500" marR="63500" marT="12700" marB="12700">
+                    <a:solidFill>
+                      <a:srgbClr val="16213A"/>
+                    </a:solidFill>
+                  </a:tcPr>
+                </a:tc>
+                <a:tc>
+                  <a:txBody>
+                    <a:bodyPr wrap="square"/>
+                    <a:lstStyle/>
+                    <a:p>
+                      <a:r>
+                        <a:rPr sz="800" b="1" i="0">
+                          <a:solidFill>
+                            <a:srgbClr val="F4F1EA"/>
+                          </a:solidFill>
+                          <a:latin typeface="Arial"/>
+                          <a:ea typeface="Malgun Gothic"/>
+                          <a:cs typeface="Malgun Gothic"/>
+                        </a:rPr>
+                        <a:t>센서</a:t>
+                      </a:r>
+                    </a:p>
+                  </a:txBody>
+                  <a:tcPr marL="63500" marR="63500" marT="12700" marB="12700">
+                    <a:solidFill>
+                      <a:srgbClr val="16213A"/>
+                    </a:solidFill>
+                  </a:tcPr>
+                </a:tc>
+                <a:tc>
+                  <a:txBody>
+                    <a:bodyPr wrap="square"/>
+                    <a:lstStyle/>
+                    <a:p>
+                      <a:r>
+                        <a:rPr sz="800" b="1" i="0">
+                          <a:solidFill>
+                            <a:srgbClr val="F4F1EA"/>
+                          </a:solidFill>
+                          <a:latin typeface="Arial"/>
+                          <a:ea typeface="Malgun Gothic"/>
+                          <a:cs typeface="Malgun Gothic"/>
+                        </a:rPr>
+                        <a:t>연산</a:t>
+                      </a:r>
+                    </a:p>
+                  </a:txBody>
+                  <a:tcPr marL="63500" marR="63500" marT="12700" marB="12700">
+                    <a:solidFill>
+                      <a:srgbClr val="16213A"/>
+                    </a:solidFill>
+                  </a:tcPr>
+                </a:tc>
+                <a:tc>
+                  <a:txBody>
+                    <a:bodyPr wrap="square"/>
+                    <a:lstStyle/>
+                    <a:p>
+                      <a:r>
+                        <a:rPr sz="800" b="1" i="0">
+                          <a:solidFill>
+                            <a:srgbClr val="F4F1EA"/>
+                          </a:solidFill>
+                          <a:latin typeface="Arial"/>
+                          <a:ea typeface="Malgun Gothic"/>
+                          <a:cs typeface="Malgun Gothic"/>
+                        </a:rPr>
+                        <a:t>합계</a:t>
+                      </a:r>
+                    </a:p>
+                  </a:txBody>
+                  <a:tcPr marL="63500" marR="63500" marT="12700" marB="12700">
+                    <a:solidFill>
+                      <a:srgbClr val="16213A"/>
+                    </a:solidFill>
+                  </a:tcPr>
+                </a:tc>
+              </a:tr>
+              <a:tr h="197088">
+                <a:tc>
+                  <a:txBody>
+                    <a:bodyPr wrap="square"/>
+                    <a:lstStyle/>
+                    <a:p>
+                      <a:r>
+                        <a:rPr sz="800" b="0" i="0">
+                          <a:solidFill>
+                            <a:srgbClr val="16213A"/>
+                          </a:solidFill>
+                          <a:latin typeface="Arial"/>
+                          <a:ea typeface="Malgun Gothic"/>
+                          <a:cs typeface="Malgun Gothic"/>
+                        </a:rPr>
+                        <a:t>A. 전면 Mid-360 + 스테레오 1 + 카메라 3</a:t>
+                      </a:r>
+                    </a:p>
+                  </a:txBody>
+                  <a:tcPr marL="63500" marR="63500" marT="12700" marB="12700">
+                    <a:solidFill>
+                      <a:srgbClr val="FFFDF8"/>
+                    </a:solidFill>
+                  </a:tcPr>
+                </a:tc>
+                <a:tc>
+                  <a:txBody>
+                    <a:bodyPr wrap="square"/>
+                    <a:lstStyle/>
+                    <a:p>
+                      <a:r>
+                        <a:rPr sz="800" b="0" i="0">
+                          <a:solidFill>
+                            <a:srgbClr val="16213A"/>
+                          </a:solidFill>
+                          <a:latin typeface="Arial"/>
+                          <a:ea typeface="Malgun Gothic"/>
+                          <a:cs typeface="Malgun Gothic"/>
+                        </a:rPr>
+                        <a:t>약 1,600–3,700달러</a:t>
+                      </a:r>
+                    </a:p>
+                  </a:txBody>
+                  <a:tcPr marL="63500" marR="63500" marT="12700" marB="12700">
+                    <a:solidFill>
+                      <a:srgbClr val="FFFDF8"/>
+                    </a:solidFill>
+                  </a:tcPr>
+                </a:tc>
+                <a:tc>
+                  <a:txBody>
+                    <a:bodyPr wrap="square"/>
+                    <a:lstStyle/>
+                    <a:p>
+                      <a:r>
+                        <a:rPr sz="800" b="0" i="0">
+                          <a:solidFill>
+                            <a:srgbClr val="16213A"/>
+                          </a:solidFill>
+                          <a:latin typeface="Arial"/>
+                          <a:ea typeface="Malgun Gothic"/>
+                          <a:cs typeface="Malgun Gothic"/>
+                        </a:rPr>
+                        <a:t>AGX Orin 32GB 1,799달러</a:t>
+                      </a:r>
+                    </a:p>
+                  </a:txBody>
+                  <a:tcPr marL="63500" marR="63500" marT="12700" marB="12700">
+                    <a:solidFill>
+                      <a:srgbClr val="FFFDF8"/>
+                    </a:solidFill>
+                  </a:tcPr>
+                </a:tc>
+                <a:tc>
+                  <a:txBody>
+                    <a:bodyPr wrap="square"/>
+                    <a:lstStyle/>
+                    <a:p>
+                      <a:r>
+                        <a:rPr sz="800" b="0" i="0">
+                          <a:solidFill>
+                            <a:srgbClr val="16213A"/>
+                          </a:solidFill>
+                          <a:latin typeface="Arial"/>
+                          <a:ea typeface="Malgun Gothic"/>
+                          <a:cs typeface="Malgun Gothic"/>
+                        </a:rPr>
+                        <a:t>약 3,400–5,500달러</a:t>
+                      </a:r>
+                    </a:p>
+                  </a:txBody>
+                  <a:tcPr marL="63500" marR="63500" marT="12700" marB="12700">
+                    <a:solidFill>
+                      <a:srgbClr val="FFFDF8"/>
+                    </a:solidFill>
+                  </a:tcPr>
+                </a:tc>
+              </a:tr>
+              <a:tr h="197088">
+                <a:tc>
+                  <a:txBody>
+                    <a:bodyPr wrap="square"/>
+                    <a:lstStyle/>
+                    <a:p>
+                      <a:r>
+                        <a:rPr sz="800" b="0" i="0">
+                          <a:solidFill>
+                            <a:srgbClr val="16213A"/>
+                          </a:solidFill>
+                          <a:latin typeface="Arial"/>
+                          <a:ea typeface="Malgun Gothic"/>
+                          <a:cs typeface="Malgun Gothic"/>
+                        </a:rPr>
+                        <a:t>A + D. 위 + 후면 L2</a:t>
+                      </a:r>
+                    </a:p>
+                  </a:txBody>
+                  <a:tcPr marL="63500" marR="63500" marT="12700" marB="12700">
+                    <a:solidFill>
+                      <a:srgbClr val="F3F0E8"/>
+                    </a:solidFill>
+                  </a:tcPr>
+                </a:tc>
+                <a:tc>
+                  <a:txBody>
+                    <a:bodyPr wrap="square"/>
+                    <a:lstStyle/>
+                    <a:p>
+                      <a:r>
+                        <a:rPr sz="800" b="0" i="0">
+                          <a:solidFill>
+                            <a:srgbClr val="16213A"/>
+                          </a:solidFill>
+                          <a:latin typeface="Arial"/>
+                          <a:ea typeface="Malgun Gothic"/>
+                          <a:cs typeface="Malgun Gothic"/>
+                        </a:rPr>
+                        <a:t>약 2,000–4,100달러</a:t>
+                      </a:r>
+                    </a:p>
+                  </a:txBody>
+                  <a:tcPr marL="63500" marR="63500" marT="12700" marB="12700">
+                    <a:solidFill>
+                      <a:srgbClr val="F3F0E8"/>
+                    </a:solidFill>
+                  </a:tcPr>
+                </a:tc>
+                <a:tc>
+                  <a:txBody>
+                    <a:bodyPr wrap="square"/>
+                    <a:lstStyle/>
+                    <a:p>
+                      <a:r>
+                        <a:rPr sz="800" b="0" i="0">
+                          <a:solidFill>
+                            <a:srgbClr val="16213A"/>
+                          </a:solidFill>
+                          <a:latin typeface="Arial"/>
+                          <a:ea typeface="Malgun Gothic"/>
+                          <a:cs typeface="Malgun Gothic"/>
+                        </a:rPr>
+                        <a:t>같음</a:t>
+                      </a:r>
+                    </a:p>
+                  </a:txBody>
+                  <a:tcPr marL="63500" marR="63500" marT="12700" marB="12700">
+                    <a:solidFill>
+                      <a:srgbClr val="F3F0E8"/>
+                    </a:solidFill>
+                  </a:tcPr>
+                </a:tc>
+                <a:tc>
+                  <a:txBody>
+                    <a:bodyPr wrap="square"/>
+                    <a:lstStyle/>
+                    <a:p>
+                      <a:r>
+                        <a:rPr sz="800" b="0" i="0">
+                          <a:solidFill>
+                            <a:srgbClr val="16213A"/>
+                          </a:solidFill>
+                          <a:latin typeface="Arial"/>
+                          <a:ea typeface="Malgun Gothic"/>
+                          <a:cs typeface="Malgun Gothic"/>
+                        </a:rPr>
+                        <a:t>약 3,800–5,900달러</a:t>
+                      </a:r>
+                    </a:p>
+                  </a:txBody>
+                  <a:tcPr marL="63500" marR="63500" marT="12700" marB="12700">
+                    <a:solidFill>
+                      <a:srgbClr val="F3F0E8"/>
+                    </a:solidFill>
+                  </a:tcPr>
+                </a:tc>
+              </a:tr>
+              <a:tr h="197088">
+                <a:tc>
+                  <a:txBody>
+                    <a:bodyPr wrap="square"/>
+                    <a:lstStyle/>
+                    <a:p>
+                      <a:r>
+                        <a:rPr sz="800" b="0" i="0">
+                          <a:solidFill>
+                            <a:srgbClr val="16213A"/>
+                          </a:solidFill>
+                          <a:latin typeface="Arial"/>
+                          <a:ea typeface="Malgun Gothic"/>
+                          <a:cs typeface="Malgun Gothic"/>
+                        </a:rPr>
+                        <a:t>B. Ouster 32채널 + 스테레오 + 카메라 3</a:t>
+                      </a:r>
+                    </a:p>
+                  </a:txBody>
+                  <a:tcPr marL="63500" marR="63500" marT="12700" marB="12700">
+                    <a:solidFill>
+                      <a:srgbClr val="FFFDF8"/>
+                    </a:solidFill>
+                  </a:tcPr>
+                </a:tc>
+                <a:tc>
+                  <a:txBody>
+                    <a:bodyPr wrap="square"/>
+                    <a:lstStyle/>
+                    <a:p>
+                      <a:r>
+                        <a:rPr sz="800" b="0" i="0">
+                          <a:solidFill>
+                            <a:srgbClr val="16213A"/>
+                          </a:solidFill>
+                          <a:latin typeface="Arial"/>
+                          <a:ea typeface="Malgun Gothic"/>
+                          <a:cs typeface="Malgun Gothic"/>
+                        </a:rPr>
+                        <a:t>약 7,100–8,300달러</a:t>
+                      </a:r>
+                    </a:p>
+                  </a:txBody>
+                  <a:tcPr marL="63500" marR="63500" marT="12700" marB="12700">
+                    <a:solidFill>
+                      <a:srgbClr val="FFFDF8"/>
+                    </a:solidFill>
+                  </a:tcPr>
+                </a:tc>
+                <a:tc>
+                  <a:txBody>
+                    <a:bodyPr wrap="square"/>
+                    <a:lstStyle/>
+                    <a:p>
+                      <a:r>
+                        <a:rPr sz="800" b="0" i="0">
+                          <a:solidFill>
+                            <a:srgbClr val="16213A"/>
+                          </a:solidFill>
+                          <a:latin typeface="Arial"/>
+                          <a:ea typeface="Malgun Gothic"/>
+                          <a:cs typeface="Malgun Gothic"/>
+                        </a:rPr>
+                        <a:t>같음</a:t>
+                      </a:r>
+                    </a:p>
+                  </a:txBody>
+                  <a:tcPr marL="63500" marR="63500" marT="12700" marB="12700">
+                    <a:solidFill>
+                      <a:srgbClr val="FFFDF8"/>
+                    </a:solidFill>
+                  </a:tcPr>
+                </a:tc>
+                <a:tc>
+                  <a:txBody>
+                    <a:bodyPr wrap="square"/>
+                    <a:lstStyle/>
+                    <a:p>
+                      <a:r>
+                        <a:rPr sz="800" b="0" i="0">
+                          <a:solidFill>
+                            <a:srgbClr val="16213A"/>
+                          </a:solidFill>
+                          <a:latin typeface="Arial"/>
+                          <a:ea typeface="Malgun Gothic"/>
+                          <a:cs typeface="Malgun Gothic"/>
+                        </a:rPr>
+                        <a:t>약 8,900–10,100달러</a:t>
+                      </a:r>
+                    </a:p>
+                  </a:txBody>
+                  <a:tcPr marL="63500" marR="63500" marT="12700" marB="12700">
+                    <a:solidFill>
+                      <a:srgbClr val="FFFDF8"/>
+                    </a:solidFill>
+                  </a:tcPr>
+                </a:tc>
+              </a:tr>
+              <a:tr h="197088">
+                <a:tc>
+                  <a:txBody>
+                    <a:bodyPr wrap="square"/>
+                    <a:lstStyle/>
+                    <a:p>
+                      <a:r>
+                        <a:rPr sz="800" b="0" i="0">
+                          <a:solidFill>
+                            <a:srgbClr val="16213A"/>
+                          </a:solidFill>
+                          <a:latin typeface="Arial"/>
+                          <a:ea typeface="Malgun Gothic"/>
+                          <a:cs typeface="Malgun Gothic"/>
+                        </a:rPr>
+                        <a:t>C. 카메라 10대 이상 + 초음파·레이더</a:t>
+                      </a:r>
+                    </a:p>
+                  </a:txBody>
+                  <a:tcPr marL="63500" marR="63500" marT="12700" marB="12700">
+                    <a:solidFill>
+                      <a:srgbClr val="F3F0E8"/>
+                    </a:solidFill>
+                  </a:tcPr>
+                </a:tc>
+                <a:tc>
+                  <a:txBody>
+                    <a:bodyPr wrap="square"/>
+                    <a:lstStyle/>
+                    <a:p>
+                      <a:r>
+                        <a:rPr sz="800" b="0" i="0">
+                          <a:solidFill>
+                            <a:srgbClr val="16213A"/>
+                          </a:solidFill>
+                          <a:latin typeface="Arial"/>
+                          <a:ea typeface="Malgun Gothic"/>
+                          <a:cs typeface="Malgun Gothic"/>
+                        </a:rPr>
+                        <a:t>약 2,000–6,000달러</a:t>
+                      </a:r>
+                    </a:p>
+                  </a:txBody>
+                  <a:tcPr marL="63500" marR="63500" marT="12700" marB="12700">
+                    <a:solidFill>
+                      <a:srgbClr val="F3F0E8"/>
+                    </a:solidFill>
+                  </a:tcPr>
+                </a:tc>
+                <a:tc>
+                  <a:txBody>
+                    <a:bodyPr wrap="square"/>
+                    <a:lstStyle/>
+                    <a:p>
+                      <a:r>
+                        <a:rPr sz="800" b="0" i="0">
+                          <a:solidFill>
+                            <a:srgbClr val="16213A"/>
+                          </a:solidFill>
+                          <a:latin typeface="Arial"/>
+                          <a:ea typeface="Malgun Gothic"/>
+                          <a:cs typeface="Malgun Gothic"/>
+                        </a:rPr>
+                        <a:t>AGX Orin 64GB 2,999달러(학습 모델 부하)</a:t>
+                      </a:r>
+                    </a:p>
+                  </a:txBody>
+                  <a:tcPr marL="63500" marR="63500" marT="12700" marB="12700">
+                    <a:solidFill>
+                      <a:srgbClr val="F3F0E8"/>
+                    </a:solidFill>
+                  </a:tcPr>
+                </a:tc>
+                <a:tc>
+                  <a:txBody>
+                    <a:bodyPr wrap="square"/>
+                    <a:lstStyle/>
+                    <a:p>
+                      <a:r>
+                        <a:rPr sz="800" b="0" i="0">
+                          <a:solidFill>
+                            <a:srgbClr val="16213A"/>
+                          </a:solidFill>
+                          <a:latin typeface="Arial"/>
+                          <a:ea typeface="Malgun Gothic"/>
+                          <a:cs typeface="Malgun Gothic"/>
+                        </a:rPr>
+                        <a:t>약 5,000–9,000달러</a:t>
+                      </a:r>
+                    </a:p>
+                  </a:txBody>
+                  <a:tcPr marL="63500" marR="63500" marT="12700" marB="12700">
+                    <a:solidFill>
+                      <a:srgbClr val="F3F0E8"/>
+                    </a:solidFill>
+                  </a:tcPr>
+                </a:tc>
+              </a:tr>
+            </a:tbl>
+          </a:graphicData>
+        </a:graphic>
+      </p:graphicFrame>
+    </p:spTree>
+  </p:cSld>
+  <p:clrMapOvr>
+    <a:masterClrMapping/>
+  </p:clrMapOvr>
+</p:sld>
+</file>
+
+<file path=ppt/slides/slide11.xml><?xml version="1.0" encoding="utf-8"?>
+<p:sld xmlns:a="http://schemas.openxmlformats.org/drawingml/2006/main" xmlns:p="http://schemas.openxmlformats.org/presentationml/2006/main" xmlns:r="http://schemas.openxmlformats.org/officeDocument/2006/relationships">
+  <p:cSld>
+    <p:bg>
+      <p:bgPr>
+        <a:solidFill>
+          <a:srgbClr val="F7F5F0"/>
+        </a:solidFill>
+        <a:effectLst/>
+      </p:bgPr>
+    </p:bg>
+    <p:spTree>
+      <p:nvGrpSpPr>
+        <p:cNvPr id="1" name=""/>
+        <p:cNvGrpSpPr/>
+        <p:nvPr/>
+      </p:nvGrpSpPr>
+      <p:grpSpPr/>
+      <p:sp>
+        <p:nvSpPr>
+          <p:cNvPr id="2" name="TextBox 1"/>
+          <p:cNvSpPr txBox="1"/>
+          <p:nvPr/>
+        </p:nvSpPr>
+        <p:spPr>
+          <a:xfrm>
+            <a:off x="609600" y="330200"/>
+            <a:ext cx="10972800" cy="165100"/>
+          </a:xfrm>
+          <a:prstGeom prst="rect">
+            <a:avLst/>
+          </a:prstGeom>
+          <a:noFill/>
+        </p:spPr>
+        <p:txBody>
+          <a:bodyPr wrap="square" lIns="0" rIns="0" tIns="0" bIns="0" anchor="t">
+            <a:spAutoFit/>
+            <a:normAutofit/>
+          </a:bodyPr>
+          <a:lstStyle/>
+          <a:p>
+            <a:r>
+              <a:rPr sz="850" b="1" i="0">
+                <a:solidFill>
+                  <a:srgbClr val="C2410C"/>
+                </a:solidFill>
+                <a:latin typeface="Consolas"/>
+                <a:ea typeface="Malgun Gothic"/>
+                <a:cs typeface="Malgun Gothic"/>
+              </a:rPr>
+              <a:t>센서 배치 · 가격·연산</a:t>
+            </a:r>
+          </a:p>
+        </p:txBody>
+      </p:sp>
+      <p:sp>
+        <p:nvSpPr>
+          <p:cNvPr id="3" name="TextBox 2"/>
+          <p:cNvSpPr txBox="1"/>
+          <p:nvPr/>
+        </p:nvSpPr>
+        <p:spPr>
+          <a:xfrm>
+            <a:off x="609600" y="558800"/>
+            <a:ext cx="10972800" cy="381000"/>
+          </a:xfrm>
+          <a:prstGeom prst="rect">
+            <a:avLst/>
+          </a:prstGeom>
+          <a:noFill/>
+        </p:spPr>
+        <p:txBody>
+          <a:bodyPr wrap="square" lIns="0" rIns="0" tIns="0" bIns="0" anchor="t">
+            <a:spAutoFit/>
+            <a:normAutofit/>
+          </a:bodyPr>
+          <a:lstStyle/>
+          <a:p>
+            <a:r>
+              <a:rPr sz="2000" b="1" i="0">
+                <a:solidFill>
+                  <a:srgbClr val="16213A"/>
+                </a:solidFill>
+                <a:latin typeface="Arial"/>
+                <a:ea typeface="Malgun Gothic"/>
+                <a:cs typeface="Malgun Gothic"/>
+              </a:rPr>
+              <a:t>H.3 예상 가격 (2026-09 기준)</a:t>
+            </a:r>
+            <a:r>
+              <a:rPr sz="1050" b="0" i="0">
+                <a:solidFill>
+                  <a:srgbClr val="5A6478"/>
+                </a:solidFill>
+                <a:latin typeface="Arial"/>
+                <a:ea typeface="Malgun Gothic"/>
+                <a:cs typeface="Malgun Gothic"/>
+              </a:rPr>
+              <a:t>  2/2</a:t>
+            </a:r>
+          </a:p>
+        </p:txBody>
+      </p:sp>
+      <p:sp>
+        <p:nvSpPr>
+          <p:cNvPr id="4" name="TextBox 3"/>
+          <p:cNvSpPr txBox="1"/>
+          <p:nvPr/>
+        </p:nvSpPr>
+        <p:spPr>
+          <a:xfrm>
+            <a:off x="609600" y="6502400"/>
+            <a:ext cx="10972800" cy="152400"/>
+          </a:xfrm>
+          <a:prstGeom prst="rect">
+            <a:avLst/>
+          </a:prstGeom>
+          <a:noFill/>
+        </p:spPr>
+        <p:txBody>
+          <a:bodyPr wrap="square" lIns="0" rIns="0" tIns="0" bIns="0" anchor="t">
+            <a:spAutoFit/>
+            <a:normAutofit/>
+          </a:bodyPr>
+          <a:lstStyle/>
+          <a:p>
+            <a:r>
+              <a:rPr sz="650" b="0" i="0">
+                <a:solidFill>
+                  <a:srgbClr val="5A6478"/>
+                </a:solidFill>
+                <a:latin typeface="Arial"/>
+                <a:ea typeface="Malgun Gothic"/>
+                <a:cs typeface="Malgun Gothic"/>
+              </a:rPr>
+              <a:t>travplan 리서치 · 센서 배치 (docs/research-sensors.md)    11 / 14</a:t>
+            </a:r>
+          </a:p>
+        </p:txBody>
+      </p:sp>
+      <p:sp>
+        <p:nvSpPr>
+          <p:cNvPr id="5" name="TextBox 4"/>
+          <p:cNvSpPr txBox="1"/>
+          <p:nvPr/>
+        </p:nvSpPr>
+        <p:spPr>
+          <a:xfrm>
+            <a:off x="609600" y="1244600"/>
+            <a:ext cx="10972800" cy="216495"/>
+          </a:xfrm>
+          <a:prstGeom prst="rect">
+            <a:avLst/>
+          </a:prstGeom>
+          <a:noFill/>
+        </p:spPr>
+        <p:txBody>
+          <a:bodyPr wrap="square" lIns="0" rIns="0" tIns="0" bIns="0" anchor="t">
+            <a:spAutoFit/>
+            <a:normAutofit/>
+          </a:bodyPr>
+          <a:lstStyle/>
+          <a:p>
+            <a:r>
+              <a:rPr sz="1050" b="0" i="0">
+                <a:solidFill>
+                  <a:srgbClr val="16213A"/>
+                </a:solidFill>
+                <a:latin typeface="Arial"/>
+                <a:ea typeface="Malgun Gothic"/>
+                <a:cs typeface="Malgun Gothic"/>
+              </a:rPr>
+              <a:t>합계에는 배선, 캐리어 보드, 보정 장비, 방수 하우징이 빠져 있다.</a:t>
+            </a:r>
+          </a:p>
+        </p:txBody>
+      </p:sp>
+    </p:spTree>
+  </p:cSld>
+  <p:clrMapOvr>
+    <a:masterClrMapping/>
+  </p:clrMapOvr>
+</p:sld>
+</file>
+
+<file path=ppt/slides/slide12.xml><?xml version="1.0" encoding="utf-8"?>
+<p:sld xmlns:a="http://schemas.openxmlformats.org/drawingml/2006/main" xmlns:p="http://schemas.openxmlformats.org/presentationml/2006/main" xmlns:r="http://schemas.openxmlformats.org/officeDocument/2006/relationships">
+  <p:cSld>
+    <p:bg>
+      <p:bgPr>
+        <a:solidFill>
+          <a:srgbClr val="F7F5F0"/>
+        </a:solidFill>
+        <a:effectLst/>
+      </p:bgPr>
+    </p:bg>
+    <p:spTree>
+      <p:nvGrpSpPr>
+        <p:cNvPr id="1" name=""/>
+        <p:cNvGrpSpPr/>
+        <p:nvPr/>
+      </p:nvGrpSpPr>
+      <p:grpSpPr/>
+      <p:sp>
+        <p:nvSpPr>
+          <p:cNvPr id="2" name="TextBox 1"/>
+          <p:cNvSpPr txBox="1"/>
+          <p:nvPr/>
+        </p:nvSpPr>
+        <p:spPr>
+          <a:xfrm>
+            <a:off x="609600" y="330200"/>
+            <a:ext cx="10972800" cy="165100"/>
+          </a:xfrm>
+          <a:prstGeom prst="rect">
+            <a:avLst/>
+          </a:prstGeom>
+          <a:noFill/>
+        </p:spPr>
+        <p:txBody>
+          <a:bodyPr wrap="square" lIns="0" rIns="0" tIns="0" bIns="0" anchor="t">
+            <a:spAutoFit/>
+            <a:normAutofit/>
+          </a:bodyPr>
+          <a:lstStyle/>
+          <a:p>
+            <a:r>
+              <a:rPr sz="850" b="1" i="0">
+                <a:solidFill>
+                  <a:srgbClr val="C2410C"/>
+                </a:solidFill>
+                <a:latin typeface="Consolas"/>
+                <a:ea typeface="Malgun Gothic"/>
+                <a:cs typeface="Malgun Gothic"/>
+              </a:rPr>
+              <a:t>센서 배치 · 가격·연산</a:t>
+            </a:r>
+          </a:p>
+        </p:txBody>
+      </p:sp>
+      <p:sp>
+        <p:nvSpPr>
+          <p:cNvPr id="3" name="TextBox 2"/>
+          <p:cNvSpPr txBox="1"/>
+          <p:nvPr/>
+        </p:nvSpPr>
+        <p:spPr>
+          <a:xfrm>
+            <a:off x="609600" y="558800"/>
+            <a:ext cx="10972800" cy="381000"/>
+          </a:xfrm>
+          <a:prstGeom prst="rect">
+            <a:avLst/>
+          </a:prstGeom>
+          <a:noFill/>
+        </p:spPr>
+        <p:txBody>
+          <a:bodyPr wrap="square" lIns="0" rIns="0" tIns="0" bIns="0" anchor="t">
+            <a:spAutoFit/>
+            <a:normAutofit/>
+          </a:bodyPr>
+          <a:lstStyle/>
+          <a:p>
+            <a:r>
+              <a:rPr sz="2000" b="1" i="0">
+                <a:solidFill>
+                  <a:srgbClr val="16213A"/>
+                </a:solidFill>
+                <a:latin typeface="Arial"/>
+                <a:ea typeface="Malgun Gothic"/>
+                <a:cs typeface="Malgun Gothic"/>
+              </a:rPr>
+              <a:t>H.4 필요한 연산 성능</a:t>
+            </a:r>
+          </a:p>
+        </p:txBody>
+      </p:sp>
+      <p:sp>
+        <p:nvSpPr>
+          <p:cNvPr id="4" name="TextBox 3"/>
+          <p:cNvSpPr txBox="1"/>
+          <p:nvPr/>
+        </p:nvSpPr>
+        <p:spPr>
+          <a:xfrm>
+            <a:off x="609600" y="6502400"/>
+            <a:ext cx="10972800" cy="152400"/>
+          </a:xfrm>
+          <a:prstGeom prst="rect">
+            <a:avLst/>
+          </a:prstGeom>
+          <a:noFill/>
+        </p:spPr>
+        <p:txBody>
+          <a:bodyPr wrap="square" lIns="0" rIns="0" tIns="0" bIns="0" anchor="t">
+            <a:spAutoFit/>
+            <a:normAutofit/>
+          </a:bodyPr>
+          <a:lstStyle/>
+          <a:p>
+            <a:r>
+              <a:rPr sz="650" b="0" i="0">
+                <a:solidFill>
+                  <a:srgbClr val="5A6478"/>
+                </a:solidFill>
+                <a:latin typeface="Arial"/>
+                <a:ea typeface="Malgun Gothic"/>
+                <a:cs typeface="Malgun Gothic"/>
+              </a:rPr>
+              <a:t>travplan 리서치 · 센서 배치 (docs/research-sensors.md)    12 / 14</a:t>
             </a:r>
           </a:p>
         </p:txBody>
@@ -5965,7 +8023,7 @@
 </p:sld>
 </file>
 
-<file path=ppt/slides/slide11.xml><?xml version="1.0" encoding="utf-8"?>
+<file path=ppt/slides/slide13.xml><?xml version="1.0" encoding="utf-8"?>
 <p:sld xmlns:a="http://schemas.openxmlformats.org/drawingml/2006/main" xmlns:p="http://schemas.openxmlformats.org/presentationml/2006/main" xmlns:r="http://schemas.openxmlformats.org/officeDocument/2006/relationships">
   <p:cSld>
     <p:bg>
@@ -6089,7 +8147,7 @@
                 <a:ea typeface="Malgun Gothic"/>
                 <a:cs typeface="Malgun Gothic"/>
               </a:rPr>
-              <a:t>travplan 리서치 · 센서 배치 (docs/research-sensors.md)    11 / 12</a:t>
+              <a:t>travplan 리서치 · 센서 배치 (docs/research-sensors.md)    13 / 14</a:t>
             </a:r>
           </a:p>
         </p:txBody>
@@ -6169,7 +8227,7 @@
 </p:sld>
 </file>
 
-<file path=ppt/slides/slide12.xml><?xml version="1.0" encoding="utf-8"?>
+<file path=ppt/slides/slide14.xml><?xml version="1.0" encoding="utf-8"?>
 <p:sld xmlns:a="http://schemas.openxmlformats.org/drawingml/2006/main" xmlns:p="http://schemas.openxmlformats.org/presentationml/2006/main" xmlns:r="http://schemas.openxmlformats.org/officeDocument/2006/relationships">
   <p:cSld>
     <p:bg>
@@ -6293,7 +8351,7 @@
                 <a:ea typeface="Malgun Gothic"/>
                 <a:cs typeface="Malgun Gothic"/>
               </a:rPr>
-              <a:t>travplan 리서치 · 센서 배치 (docs/research-sensors.md)    12 / 12</a:t>
+              <a:t>travplan 리서치 · 센서 배치 (docs/research-sensors.md)    14 / 14</a:t>
             </a:r>
           </a:p>
         </p:txBody>
@@ -7507,7 +9565,7 @@
                 <a:ea typeface="Malgun Gothic"/>
                 <a:cs typeface="Malgun Gothic"/>
               </a:rPr>
-              <a:t>travplan 리서치 · 센서 배치 (docs/research-sensors.md)    2 / 12</a:t>
+              <a:t>travplan 리서치 · 센서 배치 (docs/research-sensors.md)    2 / 14</a:t>
             </a:r>
           </a:p>
         </p:txBody>
@@ -7714,7 +9772,7 @@
                 <a:ea typeface="Malgun Gothic"/>
                 <a:cs typeface="Malgun Gothic"/>
               </a:rPr>
-              <a:t>travplan 리서치 · 센서 배치 (docs/research-sensors.md)    3 / 12</a:t>
+              <a:t>travplan 리서치 · 센서 배치 (docs/research-sensors.md)    3 / 14</a:t>
             </a:r>
           </a:p>
         </p:txBody>
@@ -7759,6 +9817,24 @@
               <a:t>H.1 다섯 가지 배치</a:t>
             </a:r>
           </a:p>
+          <a:p>
+            <a:pPr>
+              <a:spcAft>
+                <a:spcPts val="400"/>
+              </a:spcAft>
+            </a:pPr>
+            <a:r>
+              <a:rPr sz="1000" b="1" i="0">
+                <a:solidFill>
+                  <a:srgbClr val="F59E5B"/>
+                </a:solidFill>
+                <a:latin typeface="Arial"/>
+                <a:ea typeface="Malgun Gothic"/>
+                <a:cs typeface="Malgun Gothic"/>
+              </a:rPr>
+              <a:t>H.2 센서별 장단점</a:t>
+            </a:r>
+          </a:p>
         </p:txBody>
       </p:sp>
       <p:sp>
@@ -7790,15 +9866,15 @@
               </a:spcAft>
             </a:pPr>
             <a:r>
-              <a:rPr sz="1000" b="1" i="0">
-                <a:solidFill>
-                  <a:srgbClr val="F59E5B"/>
+              <a:rPr sz="1000" b="0" i="0">
+                <a:solidFill>
+                  <a:srgbClr val="C9D1E0"/>
                 </a:solidFill>
                 <a:latin typeface="Arial"/>
                 <a:ea typeface="Malgun Gothic"/>
                 <a:cs typeface="Malgun Gothic"/>
               </a:rPr>
-              <a:t>H.2 센서별 장단점</a:t>
+              <a:t>CODEI — 센서·장착 위치·알고리즘·연산 장치를 비용 가중치로 함께 고른다</a:t>
             </a:r>
           </a:p>
         </p:txBody>
@@ -7946,7 +10022,7 @@
                 <a:ea typeface="Malgun Gothic"/>
                 <a:cs typeface="Malgun Gothic"/>
               </a:rPr>
-              <a:t>travplan 리서치 · 센서 배치 (docs/research-sensors.md)    4 / 12</a:t>
+              <a:t>travplan 리서치 · 센서 배치 (docs/research-sensors.md)    4 / 14</a:t>
             </a:r>
           </a:p>
         </p:txBody>
@@ -8417,7 +10493,7 @@
                 <a:ea typeface="Malgun Gothic"/>
                 <a:cs typeface="Malgun Gothic"/>
               </a:rPr>
-              <a:t>travplan 리서치 · 센서 배치 (docs/research-sensors.md)    5 / 12</a:t>
+              <a:t>travplan 리서치 · 센서 배치 (docs/research-sensors.md)    5 / 14</a:t>
             </a:r>
           </a:p>
         </p:txBody>
@@ -9931,7 +12007,7 @@
                 <a:ea typeface="Malgun Gothic"/>
                 <a:cs typeface="Malgun Gothic"/>
               </a:rPr>
-              <a:t>travplan 리서치 · 센서 배치 (docs/research-sensors.md)    6 / 12</a:t>
+              <a:t>travplan 리서치 · 센서 배치 (docs/research-sensors.md)    6 / 14</a:t>
             </a:r>
           </a:p>
         </p:txBody>
@@ -10762,7 +12838,7 @@
     <p:bg>
       <p:bgPr>
         <a:solidFill>
-          <a:srgbClr val="16213A"/>
+          <a:srgbClr val="F7F5F0"/>
         </a:solidFill>
         <a:effectLst/>
       </p:bgPr>
@@ -10800,13 +12876,13 @@
             <a:r>
               <a:rPr sz="850" b="1" i="0">
                 <a:solidFill>
-                  <a:srgbClr val="F59E5B"/>
+                  <a:srgbClr val="C2410C"/>
                 </a:solidFill>
                 <a:latin typeface="Consolas"/>
                 <a:ea typeface="Malgun Gothic"/>
                 <a:cs typeface="Malgun Gothic"/>
               </a:rPr>
-              <a:t>센서 배치 · 탭</a:t>
+              <a:t>센서 배치 · 배치 비교 · H.2 센서별 장단점</a:t>
             </a:r>
           </a:p>
         </p:txBody>
@@ -10819,7 +12895,7 @@
         </p:nvSpPr>
         <p:spPr>
           <a:xfrm>
-            <a:off x="609600" y="609600"/>
+            <a:off x="609600" y="558800"/>
             <a:ext cx="10972800" cy="381000"/>
           </a:xfrm>
           <a:prstGeom prst="rect">
@@ -10835,15 +12911,26 @@
           <a:lstStyle/>
           <a:p>
             <a:r>
-              <a:rPr sz="2650" b="1" i="0">
-                <a:solidFill>
-                  <a:srgbClr val="F4F1EA"/>
+              <a:rPr sz="2000" b="1" i="0">
+                <a:solidFill>
+                  <a:srgbClr val="16213A"/>
                 </a:solidFill>
                 <a:latin typeface="Arial"/>
                 <a:ea typeface="Malgun Gothic"/>
                 <a:cs typeface="Malgun Gothic"/>
               </a:rPr>
-              <a:t>가격·연산</a:t>
+              <a:t>CODEI — 센서·장착 위치·알고리즘·연산 장치를 비용 가중치로 함께 고른다</a:t>
+            </a:r>
+            <a:r>
+              <a:rPr sz="1050" b="0" i="0">
+                <a:solidFill>
+                  <a:srgbClr val="5A6478"/>
+                </a:solidFill>
+                <a:latin typeface="Arial"/>
+                <a:ea typeface="Malgun Gothic"/>
+                <a:cs typeface="Malgun Gothic"/>
+              </a:rPr>
+              <a:t>  1/2</a:t>
             </a:r>
           </a:p>
         </p:txBody>
@@ -10874,13 +12961,13 @@
             <a:r>
               <a:rPr sz="650" b="0" i="0">
                 <a:solidFill>
-                  <a:srgbClr val="9AA6BC"/>
+                  <a:srgbClr val="5A6478"/>
                 </a:solidFill>
                 <a:latin typeface="Arial"/>
                 <a:ea typeface="Malgun Gothic"/>
                 <a:cs typeface="Malgun Gothic"/>
               </a:rPr>
-              <a:t>travplan 리서치 · 센서 배치 (docs/research-sensors.md)    7 / 12</a:t>
+              <a:t>travplan 리서치 · 센서 배치 (docs/research-sensors.md)    7 / 14</a:t>
             </a:r>
           </a:p>
         </p:txBody>
@@ -10894,7 +12981,7 @@
         <p:spPr>
           <a:xfrm>
             <a:off x="609600" y="1244600"/>
-            <a:ext cx="5283200" cy="5080000"/>
+            <a:ext cx="10972800" cy="865981"/>
           </a:xfrm>
           <a:prstGeom prst="rect">
             <a:avLst/>
@@ -10908,21 +12995,94 @@
           </a:bodyPr>
           <a:lstStyle/>
           <a:p>
-            <a:pPr>
-              <a:spcAft>
-                <a:spcPts val="400"/>
-              </a:spcAft>
-            </a:pPr>
-            <a:r>
-              <a:rPr sz="1000" b="1" i="0">
-                <a:solidFill>
-                  <a:srgbClr val="F59E5B"/>
+            <a:r>
+              <a:rPr sz="1050" b="1" i="0">
+                <a:solidFill>
+                  <a:srgbClr val="16213A"/>
                 </a:solidFill>
                 <a:latin typeface="Arial"/>
                 <a:ea typeface="Malgun Gothic"/>
                 <a:cs typeface="Malgun Gothic"/>
               </a:rPr>
-              <a:t>H.3 예상 가격 (2026-09 기준)</a:t>
+              <a:t>과제가 요구하는 인식 성능과 각 센서·검출기의 측정된 오탐·미탐률을 정수 선형 계획(ILP)으로 맞춰, 가격·질량·전력·연산 가운데 무엇을 아끼느냐에 따라 센서 구성을 고른다.</a:t>
+            </a:r>
+            <a:r>
+              <a:rPr sz="1050" b="0" i="0">
+                <a:solidFill>
+                  <a:srgbClr val="16213A"/>
+                </a:solidFill>
+                <a:latin typeface="Arial"/>
+                <a:ea typeface="Malgun Gothic"/>
+                <a:cs typeface="Malgun Gothic"/>
+              </a:rPr>
+              <a:t> 논문 제목은 </a:t>
+            </a:r>
+            <a:r>
+              <a:rPr sz="1050" b="0" i="1">
+                <a:solidFill>
+                  <a:srgbClr val="16213A"/>
+                </a:solidFill>
+                <a:latin typeface="Arial"/>
+                <a:ea typeface="Malgun Gothic"/>
+                <a:cs typeface="Malgun Gothic"/>
+              </a:rPr>
+              <a:t>CODEI: Resource-Efficient Task-Driven Co-Design of Perception and Decision Making for Mobile Robots Applied to Autonomous Vehicles</a:t>
+            </a:r>
+            <a:r>
+              <a:rPr sz="1050" b="0" i="0">
+                <a:solidFill>
+                  <a:srgbClr val="16213A"/>
+                </a:solidFill>
+                <a:latin typeface="Arial"/>
+                <a:ea typeface="Malgun Gothic"/>
+                <a:cs typeface="Malgun Gothic"/>
+              </a:rPr>
+              <a:t>다 (Milojevic·Zardini·Elser·Censi·Frazzoli </a:t>
+            </a:r>
+            <a:r>
+              <a:rPr sz="1050" b="0" i="0">
+                <a:solidFill>
+                  <a:srgbClr val="1D4ED8"/>
+                </a:solidFill>
+                <a:latin typeface="Arial"/>
+                <a:ea typeface="Malgun Gothic"/>
+                <a:cs typeface="Malgun Gothic"/>
+                <a:hlinkClick r:id="rId3"/>
+              </a:rPr>
+              <a:t>arXiv:2503.10296</a:t>
+            </a:r>
+            <a:r>
+              <a:rPr sz="1050" b="0" i="0">
+                <a:solidFill>
+                  <a:srgbClr val="16213A"/>
+                </a:solidFill>
+                <a:latin typeface="Arial"/>
+                <a:ea typeface="Malgun Gothic"/>
+                <a:cs typeface="Malgun Gothic"/>
+              </a:rPr>
+              <a:t>, IEEE T-RO 2025, ETH Zürich·Empa·MIT). 코드는 확인하지 못했다. </a:t>
+            </a:r>
+            <a:r>
+              <a:rPr sz="1050" b="1" i="0">
+                <a:solidFill>
+                  <a:srgbClr val="C2410C"/>
+                </a:solidFill>
+                <a:latin typeface="Arial"/>
+                <a:ea typeface="Malgun Gothic"/>
+                <a:cs typeface="Malgun Gothic"/>
+              </a:rPr>
+              <a:t>결론은 "카메라는 싸고 가벼운 설계에, LiDAR는 전력과 연산을 아끼는 설계에"다.</a:t>
+            </a:r>
+            <a:r>
+              <a:rPr sz="1050" b="0" i="0">
+                <a:solidFill>
+                  <a:srgbClr val="16213A"/>
+                </a:solidFill>
+                <a:latin typeface="Arial"/>
+                <a:ea typeface="Malgun Gothic"/>
+                <a:cs typeface="Malgun Gothic"/>
+              </a:rPr>
+              <a:t> 복잡한 과제에서는 모든 설계가 LiDAR를 하나 이상 골랐다.</a:t>
             </a:r>
           </a:p>
         </p:txBody>
@@ -10935,8 +13095,8 @@
         </p:nvSpPr>
         <p:spPr>
           <a:xfrm>
-            <a:off x="6299200" y="1244600"/>
-            <a:ext cx="5283200" cy="5080000"/>
+            <a:off x="609600" y="2199481"/>
+            <a:ext cx="10972800" cy="865981"/>
           </a:xfrm>
           <a:prstGeom prst="rect">
             <a:avLst/>
@@ -10950,21 +13110,64 @@
           </a:bodyPr>
           <a:lstStyle/>
           <a:p>
-            <a:pPr>
-              <a:spcAft>
-                <a:spcPts val="400"/>
-              </a:spcAft>
-            </a:pPr>
-            <a:r>
-              <a:rPr sz="1000" b="1" i="0">
-                <a:solidFill>
-                  <a:srgbClr val="F59E5B"/>
+            <a:r>
+              <a:rPr sz="1050" b="0" i="0">
+                <a:solidFill>
+                  <a:srgbClr val="16213A"/>
                 </a:solidFill>
                 <a:latin typeface="Arial"/>
                 <a:ea typeface="Malgun Gothic"/>
                 <a:cs typeface="Malgun Gothic"/>
               </a:rPr>
-              <a:t>H.4 필요한 연산 성능</a:t>
+              <a:t>동작 방식은 이렇다. 표본 기반 계획기가 던지는 "이 시각에 이 자세가 부딪히는가"라는 질의(occupancy query)를, 인식이 반드시 잡아야 할 물체 배치로 바꾼다. 센서와 검출기의 짝(LiDAR + PointPillars, 카메라 + FCOS3D)은 nuScenes에서 거리·방향·크기·조명별 미탐률과 오탐률을 재 Gaussian process 분류기로 모델링한다. 장착 위치(yaw 8방향, pitch 0°)마다 광선 투사로 시야와 차체 자기 가림을 계산하고, 모든 요구를 덮는 가장 싼 조합을 ILP(결정 변수 667개, 약 75 s)로 푼다. 연산 장치 후보는 Jetson Nano부터 AGX Orin 64GB까지 일곱이다. 연산을 아끼면 Orin Nano에 카메라 없이 LiDAR만, 질량을 아끼면 카메라에 AGX Orin 64GB가 뽑혔다.</a:t>
+            </a:r>
+          </a:p>
+        </p:txBody>
+      </p:sp>
+      <p:sp>
+        <p:nvSpPr>
+          <p:cNvPr id="7" name="TextBox 6"/>
+          <p:cNvSpPr txBox="1"/>
+          <p:nvPr/>
+        </p:nvSpPr>
+        <p:spPr>
+          <a:xfrm>
+            <a:off x="609600" y="3154362"/>
+            <a:ext cx="10972800" cy="649486"/>
+          </a:xfrm>
+          <a:prstGeom prst="rect">
+            <a:avLst/>
+          </a:prstGeom>
+          <a:noFill/>
+        </p:spPr>
+        <p:txBody>
+          <a:bodyPr wrap="square" lIns="0" rIns="0" tIns="0" bIns="0" anchor="t">
+            <a:spAutoFit/>
+            <a:normAutofit/>
+          </a:bodyPr>
+          <a:lstStyle/>
+          <a:p>
+            <a:r>
+              <a:rPr sz="1050" b="1" i="0">
+                <a:solidFill>
+                  <a:srgbClr val="16213A"/>
+                </a:solidFill>
+                <a:latin typeface="Arial"/>
+                <a:ea typeface="Malgun Gothic"/>
+                <a:cs typeface="Malgun Gothic"/>
+              </a:rPr>
+              <a:t>travplan에 주는 의미.</a:t>
+            </a:r>
+            <a:r>
+              <a:rPr sz="1050" b="0" i="0">
+                <a:solidFill>
+                  <a:srgbClr val="16213A"/>
+                </a:solidFill>
+                <a:latin typeface="Arial"/>
+                <a:ea typeface="Malgun Gothic"/>
+                <a:cs typeface="Malgun Gothic"/>
+              </a:rPr>
+              <a:t> 사례 연구는 승용차(Smart·Pacifica·C63)와 자동차용 센서라 숫자를 그대로 쓸 수 없다. 가져올 것은 절차다. H.1의 다섯 배치를 감으로 비교하는 대신, travplan 시뮬에서 "Planner가 실제로 묻는 칸"을 요구로 모으고, L1 합성 센서별 미관측률을 성능으로 재면 같은 ILP로 배치를 고를 수 있다. 배달로봇에서 지형(음의 장애물)은 이 논문의 물체 검출 요구와 다르므로, 요구 정의를 TravMap 칸 단위로 바꿔야 한다.</a:t>
             </a:r>
           </a:p>
         </p:txBody>
@@ -11027,7 +13230,7 @@
                 <a:ea typeface="Malgun Gothic"/>
                 <a:cs typeface="Malgun Gothic"/>
               </a:rPr>
-              <a:t>센서 배치 · 가격·연산</a:t>
+              <a:t>센서 배치 · 배치 비교 · H.2 센서별 장단점</a:t>
             </a:r>
           </a:p>
         </p:txBody>
@@ -11064,7 +13267,7 @@
                 <a:ea typeface="Malgun Gothic"/>
                 <a:cs typeface="Malgun Gothic"/>
               </a:rPr>
-              <a:t>H.3 예상 가격 (2026-09 기준)</a:t>
+              <a:t>CODEI — 센서·장착 위치·알고리즘·연산 장치를 비용 가중치로 함께 고른다</a:t>
             </a:r>
             <a:r>
               <a:rPr sz="1050" b="0" i="0">
@@ -11075,7 +13278,7 @@
                 <a:ea typeface="Malgun Gothic"/>
                 <a:cs typeface="Malgun Gothic"/>
               </a:rPr>
-              <a:t>  1/2</a:t>
+              <a:t>  2/2</a:t>
             </a:r>
           </a:p>
         </p:txBody>
@@ -11112,21 +13315,45 @@
                 <a:ea typeface="Malgun Gothic"/>
                 <a:cs typeface="Malgun Gothic"/>
               </a:rPr>
-              <a:t>travplan 리서치 · 센서 배치 (docs/research-sensors.md)    8 / 12</a:t>
-            </a:r>
-          </a:p>
-        </p:txBody>
-      </p:sp>
-      <p:sp>
-        <p:nvSpPr>
-          <p:cNvPr id="5" name="TextBox 4"/>
+              <a:t>travplan 리서치 · 센서 배치 (docs/research-sensors.md)    8 / 14</a:t>
+            </a:r>
+          </a:p>
+        </p:txBody>
+      </p:sp>
+      <p:pic>
+        <p:nvPicPr>
+          <p:cNvPr id="5" name="Picture 4" descr="image.jpg"/>
+          <p:cNvPicPr>
+            <a:picLocks noChangeAspect="1"/>
+          </p:cNvPicPr>
+          <p:nvPr/>
+        </p:nvPicPr>
+        <p:blipFill>
+          <a:blip r:embed="rId3"/>
+          <a:stretch>
+            <a:fillRect/>
+          </a:stretch>
+        </p:blipFill>
+        <p:spPr>
+          <a:xfrm>
+            <a:off x="3536950" y="1244600"/>
+            <a:ext cx="5118100" cy="4445000"/>
+          </a:xfrm>
+          <a:prstGeom prst="rect">
+            <a:avLst/>
+          </a:prstGeom>
+        </p:spPr>
+      </p:pic>
+      <p:sp>
+        <p:nvSpPr>
+          <p:cNvPr id="6" name="TextBox 5"/>
           <p:cNvSpPr txBox="1"/>
           <p:nvPr/>
         </p:nvSpPr>
         <p:spPr>
           <a:xfrm>
-            <a:off x="609600" y="1244600"/>
-            <a:ext cx="10972800" cy="216495"/>
+            <a:off x="3536950" y="5727700"/>
+            <a:ext cx="5118100" cy="284361"/>
           </a:xfrm>
           <a:prstGeom prst="rect">
             <a:avLst/>
@@ -11141,1565 +13368,19 @@
           <a:lstStyle/>
           <a:p>
             <a:r>
-              <a:rPr sz="1050" b="1" i="0">
-                <a:solidFill>
-                  <a:srgbClr val="16213A"/>
+              <a:rPr sz="750" b="0" i="0">
+                <a:solidFill>
+                  <a:srgbClr val="5A6478"/>
                 </a:solidFill>
                 <a:latin typeface="Arial"/>
                 <a:ea typeface="Malgun Gothic"/>
                 <a:cs typeface="Malgun Gothic"/>
               </a:rPr>
-              <a:t>가격은 판매처와 시점에 따라 두 배 가까이 차이 난다. 특히 NVIDIA Jetson은 2026-07에 최대 101% 올랐다.</a:t>
-            </a:r>
-            <a:r>
-              <a:rPr sz="1050" b="0" i="0">
-                <a:solidFill>
-                  <a:srgbClr val="16213A"/>
-                </a:solidFill>
-                <a:latin typeface="Arial"/>
-                <a:ea typeface="Malgun Gothic"/>
-                <a:cs typeface="Malgun Gothic"/>
-              </a:rPr>
-              <a:t> 아래는 공개 가격이고, 양산 수량 가격은 별도 견적이다.</a:t>
-            </a:r>
-          </a:p>
-        </p:txBody>
-      </p:sp>
-      <p:graphicFrame>
-        <p:nvGraphicFramePr>
-          <p:cNvPr id="6" name="Table 5"/>
-          <p:cNvGraphicFramePr>
-            <a:graphicFrameLocks noGrp="1"/>
-          </p:cNvGraphicFramePr>
-          <p:nvPr/>
-        </p:nvGraphicFramePr>
-        <p:xfrm>
-          <a:off x="609600" y="1549995"/>
-          <a:ext cx="10966450" cy="2365056"/>
-        </p:xfrm>
-        <a:graphic>
-          <a:graphicData uri="http://schemas.openxmlformats.org/drawingml/2006/table">
-            <a:tbl>
-              <a:tblPr firstRow="1" bandRow="1">
-                <a:tableStyleId>{5C22544A-7EE6-4342-B048-85BDC9FD1C3A}</a:tableStyleId>
-              </a:tblPr>
-              <a:tblGrid>
-                <a:gridCol w="4859238"/>
-                <a:gridCol w="4035723"/>
-                <a:gridCol w="2071489"/>
-              </a:tblGrid>
-              <a:tr h="197088">
-                <a:tc>
-                  <a:txBody>
-                    <a:bodyPr wrap="square"/>
-                    <a:lstStyle/>
-                    <a:p>
-                      <a:r>
-                        <a:rPr sz="800" b="1" i="0">
-                          <a:solidFill>
-                            <a:srgbClr val="F4F1EA"/>
-                          </a:solidFill>
-                          <a:latin typeface="Arial"/>
-                          <a:ea typeface="Malgun Gothic"/>
-                          <a:cs typeface="Malgun Gothic"/>
-                        </a:rPr>
-                        <a:t>품목</a:t>
-                      </a:r>
-                    </a:p>
-                  </a:txBody>
-                  <a:tcPr marL="63500" marR="63500" marT="12700" marB="12700">
-                    <a:solidFill>
-                      <a:srgbClr val="16213A"/>
-                    </a:solidFill>
-                  </a:tcPr>
-                </a:tc>
-                <a:tc>
-                  <a:txBody>
-                    <a:bodyPr wrap="square"/>
-                    <a:lstStyle/>
-                    <a:p>
-                      <a:r>
-                        <a:rPr sz="800" b="1" i="0">
-                          <a:solidFill>
-                            <a:srgbClr val="F4F1EA"/>
-                          </a:solidFill>
-                          <a:latin typeface="Arial"/>
-                          <a:ea typeface="Malgun Gothic"/>
-                          <a:cs typeface="Malgun Gothic"/>
-                        </a:rPr>
-                        <a:t>가격</a:t>
-                      </a:r>
-                    </a:p>
-                  </a:txBody>
-                  <a:tcPr marL="63500" marR="63500" marT="12700" marB="12700">
-                    <a:solidFill>
-                      <a:srgbClr val="16213A"/>
-                    </a:solidFill>
-                  </a:tcPr>
-                </a:tc>
-                <a:tc>
-                  <a:txBody>
-                    <a:bodyPr wrap="square"/>
-                    <a:lstStyle/>
-                    <a:p>
-                      <a:r>
-                        <a:rPr sz="800" b="1" i="0">
-                          <a:solidFill>
-                            <a:srgbClr val="F4F1EA"/>
-                          </a:solidFill>
-                          <a:latin typeface="Arial"/>
-                          <a:ea typeface="Malgun Gothic"/>
-                          <a:cs typeface="Malgun Gothic"/>
-                        </a:rPr>
-                        <a:t>출처</a:t>
-                      </a:r>
-                    </a:p>
-                  </a:txBody>
-                  <a:tcPr marL="63500" marR="63500" marT="12700" marB="12700">
-                    <a:solidFill>
-                      <a:srgbClr val="16213A"/>
-                    </a:solidFill>
-                  </a:tcPr>
-                </a:tc>
-              </a:tr>
-              <a:tr h="197088">
-                <a:tc>
-                  <a:txBody>
-                    <a:bodyPr wrap="square"/>
-                    <a:lstStyle/>
-                    <a:p>
-                      <a:r>
-                        <a:rPr sz="800" b="0" i="0">
-                          <a:solidFill>
-                            <a:srgbClr val="16213A"/>
-                          </a:solidFill>
-                          <a:latin typeface="Arial"/>
-                          <a:ea typeface="Malgun Gothic"/>
-                          <a:cs typeface="Malgun Gothic"/>
-                        </a:rPr>
-                        <a:t>Livox Mid-360(360° × 59°, 10 Hz, 초당 20만 점)</a:t>
-                      </a:r>
-                    </a:p>
-                  </a:txBody>
-                  <a:tcPr marL="63500" marR="63500" marT="12700" marB="12700">
-                    <a:solidFill>
-                      <a:srgbClr val="FFFDF8"/>
-                    </a:solidFill>
-                  </a:tcPr>
-                </a:tc>
-                <a:tc>
-                  <a:txBody>
-                    <a:bodyPr wrap="square"/>
-                    <a:lstStyle/>
-                    <a:p>
-                      <a:r>
-                        <a:rPr sz="800" b="0" i="0">
-                          <a:solidFill>
-                            <a:srgbClr val="16213A"/>
-                          </a:solidFill>
-                          <a:latin typeface="Arial"/>
-                          <a:ea typeface="Malgun Gothic"/>
-                          <a:cs typeface="Malgun Gothic"/>
-                        </a:rPr>
-                        <a:t>소매 약 480–1,350달러(판매처별)</a:t>
-                      </a:r>
-                    </a:p>
-                  </a:txBody>
-                  <a:tcPr marL="63500" marR="63500" marT="12700" marB="12700">
-                    <a:solidFill>
-                      <a:srgbClr val="FFFDF8"/>
-                    </a:solidFill>
-                  </a:tcPr>
-                </a:tc>
-                <a:tc>
-                  <a:txBody>
-                    <a:bodyPr wrap="square"/>
-                    <a:lstStyle/>
-                    <a:p>
-                      <a:r>
-                        <a:rPr sz="800" b="0" i="0">
-                          <a:solidFill>
-                            <a:srgbClr val="1D4ED8"/>
-                          </a:solidFill>
-                          <a:latin typeface="Arial"/>
-                          <a:ea typeface="Malgun Gothic"/>
-                          <a:cs typeface="Malgun Gothic"/>
-                          <a:hlinkClick r:id="rId3"/>
-                        </a:rPr>
-                        <a:t>Livox 사양</a:t>
-                      </a:r>
-                      <a:r>
-                        <a:rPr sz="800" b="0" i="0">
-                          <a:solidFill>
-                            <a:srgbClr val="16213A"/>
-                          </a:solidFill>
-                          <a:latin typeface="Arial"/>
-                          <a:ea typeface="Malgun Gothic"/>
-                          <a:cs typeface="Malgun Gothic"/>
-                        </a:rPr>
-                        <a:t>, </a:t>
-                      </a:r>
-                      <a:r>
-                        <a:rPr sz="800" b="0" i="0">
-                          <a:solidFill>
-                            <a:srgbClr val="1D4ED8"/>
-                          </a:solidFill>
-                          <a:latin typeface="Arial"/>
-                          <a:ea typeface="Malgun Gothic"/>
-                          <a:cs typeface="Malgun Gothic"/>
-                          <a:hlinkClick r:id="rId4"/>
-                        </a:rPr>
-                        <a:t>Vertex</a:t>
-                      </a:r>
-                    </a:p>
-                  </a:txBody>
-                  <a:tcPr marL="63500" marR="63500" marT="12700" marB="12700">
-                    <a:solidFill>
-                      <a:srgbClr val="FFFDF8"/>
-                    </a:solidFill>
-                  </a:tcPr>
-                </a:tc>
-              </a:tr>
-              <a:tr h="197088">
-                <a:tc>
-                  <a:txBody>
-                    <a:bodyPr wrap="square"/>
-                    <a:lstStyle/>
-                    <a:p>
-                      <a:r>
-                        <a:rPr sz="800" b="0" i="0">
-                          <a:solidFill>
-                            <a:srgbClr val="16213A"/>
-                          </a:solidFill>
-                          <a:latin typeface="Arial"/>
-                          <a:ea typeface="Malgun Gothic"/>
-                          <a:cs typeface="Malgun Gothic"/>
-                        </a:rPr>
-                        <a:t>Unitree 4D LiDAR L2(360° × 96°, 30 m)</a:t>
-                      </a:r>
-                    </a:p>
-                  </a:txBody>
-                  <a:tcPr marL="63500" marR="63500" marT="12700" marB="12700">
-                    <a:solidFill>
-                      <a:srgbClr val="F3F0E8"/>
-                    </a:solidFill>
-                  </a:tcPr>
-                </a:tc>
-                <a:tc>
-                  <a:txBody>
-                    <a:bodyPr wrap="square"/>
-                    <a:lstStyle/>
-                    <a:p>
-                      <a:r>
-                        <a:rPr sz="800" b="0" i="0">
-                          <a:solidFill>
-                            <a:srgbClr val="16213A"/>
-                          </a:solidFill>
-                          <a:latin typeface="Arial"/>
-                          <a:ea typeface="Malgun Gothic"/>
-                          <a:cs typeface="Malgun Gothic"/>
-                        </a:rPr>
-                        <a:t>419달러</a:t>
-                      </a:r>
-                    </a:p>
-                  </a:txBody>
-                  <a:tcPr marL="63500" marR="63500" marT="12700" marB="12700">
-                    <a:solidFill>
-                      <a:srgbClr val="F3F0E8"/>
-                    </a:solidFill>
-                  </a:tcPr>
-                </a:tc>
-                <a:tc>
-                  <a:txBody>
-                    <a:bodyPr wrap="square"/>
-                    <a:lstStyle/>
-                    <a:p>
-                      <a:r>
-                        <a:rPr sz="800" b="0" i="0">
-                          <a:solidFill>
-                            <a:srgbClr val="1D4ED8"/>
-                          </a:solidFill>
-                          <a:latin typeface="Arial"/>
-                          <a:ea typeface="Malgun Gothic"/>
-                          <a:cs typeface="Malgun Gothic"/>
-                          <a:hlinkClick r:id="rId5"/>
-                        </a:rPr>
-                        <a:t>Unitree</a:t>
-                      </a:r>
-                    </a:p>
-                  </a:txBody>
-                  <a:tcPr marL="63500" marR="63500" marT="12700" marB="12700">
-                    <a:solidFill>
-                      <a:srgbClr val="F3F0E8"/>
-                    </a:solidFill>
-                  </a:tcPr>
-                </a:tc>
-              </a:tr>
-              <a:tr h="197088">
-                <a:tc>
-                  <a:txBody>
-                    <a:bodyPr wrap="square"/>
-                    <a:lstStyle/>
-                    <a:p>
-                      <a:r>
-                        <a:rPr sz="800" b="0" i="0">
-                          <a:solidFill>
-                            <a:srgbClr val="16213A"/>
-                          </a:solidFill>
-                          <a:latin typeface="Arial"/>
-                          <a:ea typeface="Malgun Gothic"/>
-                          <a:cs typeface="Malgun Gothic"/>
-                        </a:rPr>
-                        <a:t>Ouster OS1-32</a:t>
-                      </a:r>
-                    </a:p>
-                  </a:txBody>
-                  <a:tcPr marL="63500" marR="63500" marT="12700" marB="12700">
-                    <a:solidFill>
-                      <a:srgbClr val="FFFDF8"/>
-                    </a:solidFill>
-                  </a:tcPr>
-                </a:tc>
-                <a:tc>
-                  <a:txBody>
-                    <a:bodyPr wrap="square"/>
-                    <a:lstStyle/>
-                    <a:p>
-                      <a:r>
-                        <a:rPr sz="800" b="0" i="0">
-                          <a:solidFill>
-                            <a:srgbClr val="16213A"/>
-                          </a:solidFill>
-                          <a:latin typeface="Arial"/>
-                          <a:ea typeface="Malgun Gothic"/>
-                          <a:cs typeface="Malgun Gothic"/>
-                        </a:rPr>
-                        <a:t>6,000달러부터(출시 당시)</a:t>
-                      </a:r>
-                    </a:p>
-                  </a:txBody>
-                  <a:tcPr marL="63500" marR="63500" marT="12700" marB="12700">
-                    <a:solidFill>
-                      <a:srgbClr val="FFFDF8"/>
-                    </a:solidFill>
-                  </a:tcPr>
-                </a:tc>
-                <a:tc>
-                  <a:txBody>
-                    <a:bodyPr wrap="square"/>
-                    <a:lstStyle/>
-                    <a:p>
-                      <a:r>
-                        <a:rPr sz="800" b="0" i="0">
-                          <a:solidFill>
-                            <a:srgbClr val="1D4ED8"/>
-                          </a:solidFill>
-                          <a:latin typeface="Arial"/>
-                          <a:ea typeface="Malgun Gothic"/>
-                          <a:cs typeface="Malgun Gothic"/>
-                          <a:hlinkClick r:id="rId6"/>
-                        </a:rPr>
-                        <a:t>Ouster</a:t>
-                      </a:r>
-                    </a:p>
-                  </a:txBody>
-                  <a:tcPr marL="63500" marR="63500" marT="12700" marB="12700">
-                    <a:solidFill>
-                      <a:srgbClr val="FFFDF8"/>
-                    </a:solidFill>
-                  </a:tcPr>
-                </a:tc>
-              </a:tr>
-              <a:tr h="197088">
-                <a:tc>
-                  <a:txBody>
-                    <a:bodyPr wrap="square"/>
-                    <a:lstStyle/>
-                    <a:p>
-                      <a:r>
-                        <a:rPr sz="800" b="0" i="0">
-                          <a:solidFill>
-                            <a:srgbClr val="16213A"/>
-                          </a:solidFill>
-                          <a:latin typeface="Arial"/>
-                          <a:ea typeface="Malgun Gothic"/>
-                          <a:cs typeface="Malgun Gothic"/>
-                        </a:rPr>
-                        <a:t>RoboSense Airy, Hesai JT128</a:t>
-                      </a:r>
-                    </a:p>
-                  </a:txBody>
-                  <a:tcPr marL="63500" marR="63500" marT="12700" marB="12700">
-                    <a:solidFill>
-                      <a:srgbClr val="F3F0E8"/>
-                    </a:solidFill>
-                  </a:tcPr>
-                </a:tc>
-                <a:tc>
-                  <a:txBody>
-                    <a:bodyPr wrap="square"/>
-                    <a:lstStyle/>
-                    <a:p>
-                      <a:r>
-                        <a:rPr sz="800" b="0" i="0">
-                          <a:solidFill>
-                            <a:srgbClr val="16213A"/>
-                          </a:solidFill>
-                          <a:latin typeface="Arial"/>
-                          <a:ea typeface="Malgun Gothic"/>
-                          <a:cs typeface="Malgun Gothic"/>
-                        </a:rPr>
-                        <a:t>견적</a:t>
-                      </a:r>
-                    </a:p>
-                  </a:txBody>
-                  <a:tcPr marL="63500" marR="63500" marT="12700" marB="12700">
-                    <a:solidFill>
-                      <a:srgbClr val="F3F0E8"/>
-                    </a:solidFill>
-                  </a:tcPr>
-                </a:tc>
-                <a:tc>
-                  <a:txBody>
-                    <a:bodyPr wrap="square"/>
-                    <a:lstStyle/>
-                    <a:p>
-                      <a:r>
-                        <a:rPr sz="800" b="0" i="0">
-                          <a:solidFill>
-                            <a:srgbClr val="1D4ED8"/>
-                          </a:solidFill>
-                          <a:latin typeface="Arial"/>
-                          <a:ea typeface="Malgun Gothic"/>
-                          <a:cs typeface="Malgun Gothic"/>
-                          <a:hlinkClick r:id="rId7"/>
-                        </a:rPr>
-                        <a:t>RoboSense</a:t>
-                      </a:r>
-                      <a:r>
-                        <a:rPr sz="800" b="0" i="0">
-                          <a:solidFill>
-                            <a:srgbClr val="16213A"/>
-                          </a:solidFill>
-                          <a:latin typeface="Arial"/>
-                          <a:ea typeface="Malgun Gothic"/>
-                          <a:cs typeface="Malgun Gothic"/>
-                        </a:rPr>
-                        <a:t>, </a:t>
-                      </a:r>
-                      <a:r>
-                        <a:rPr sz="800" b="0" i="0">
-                          <a:solidFill>
-                            <a:srgbClr val="1D4ED8"/>
-                          </a:solidFill>
-                          <a:latin typeface="Arial"/>
-                          <a:ea typeface="Malgun Gothic"/>
-                          <a:cs typeface="Malgun Gothic"/>
-                          <a:hlinkClick r:id="rId8"/>
-                        </a:rPr>
-                        <a:t>Hesai</a:t>
-                      </a:r>
-                    </a:p>
-                  </a:txBody>
-                  <a:tcPr marL="63500" marR="63500" marT="12700" marB="12700">
-                    <a:solidFill>
-                      <a:srgbClr val="F3F0E8"/>
-                    </a:solidFill>
-                  </a:tcPr>
-                </a:tc>
-              </a:tr>
-              <a:tr h="197088">
-                <a:tc>
-                  <a:txBody>
-                    <a:bodyPr wrap="square"/>
-                    <a:lstStyle/>
-                    <a:p>
-                      <a:r>
-                        <a:rPr sz="800" b="0" i="0">
-                          <a:solidFill>
-                            <a:srgbClr val="16213A"/>
-                          </a:solidFill>
-                          <a:latin typeface="Arial"/>
-                          <a:ea typeface="Malgun Gothic"/>
-                          <a:cs typeface="Malgun Gothic"/>
-                        </a:rPr>
-                        <a:t>Stereolabs ZED X Mini(GMSL2 스테레오)</a:t>
-                      </a:r>
-                    </a:p>
-                  </a:txBody>
-                  <a:tcPr marL="63500" marR="63500" marT="12700" marB="12700">
-                    <a:solidFill>
-                      <a:srgbClr val="FFFDF8"/>
-                    </a:solidFill>
-                  </a:tcPr>
-                </a:tc>
-                <a:tc>
-                  <a:txBody>
-                    <a:bodyPr wrap="square"/>
-                    <a:lstStyle/>
-                    <a:p>
-                      <a:r>
-                        <a:rPr sz="800" b="0" i="0">
-                          <a:solidFill>
-                            <a:srgbClr val="16213A"/>
-                          </a:solidFill>
-                          <a:latin typeface="Arial"/>
-                          <a:ea typeface="Malgun Gothic"/>
-                          <a:cs typeface="Malgun Gothic"/>
-                        </a:rPr>
-                        <a:t>549달러</a:t>
-                      </a:r>
-                    </a:p>
-                  </a:txBody>
-                  <a:tcPr marL="63500" marR="63500" marT="12700" marB="12700">
-                    <a:solidFill>
-                      <a:srgbClr val="FFFDF8"/>
-                    </a:solidFill>
-                  </a:tcPr>
-                </a:tc>
-                <a:tc>
-                  <a:txBody>
-                    <a:bodyPr wrap="square"/>
-                    <a:lstStyle/>
-                    <a:p>
-                      <a:r>
-                        <a:rPr sz="800" b="0" i="0">
-                          <a:solidFill>
-                            <a:srgbClr val="1D4ED8"/>
-                          </a:solidFill>
-                          <a:latin typeface="Arial"/>
-                          <a:ea typeface="Malgun Gothic"/>
-                          <a:cs typeface="Malgun Gothic"/>
-                          <a:hlinkClick r:id="rId9"/>
-                        </a:rPr>
-                        <a:t>Stereolabs</a:t>
-                      </a:r>
-                    </a:p>
-                  </a:txBody>
-                  <a:tcPr marL="63500" marR="63500" marT="12700" marB="12700">
-                    <a:solidFill>
-                      <a:srgbClr val="FFFDF8"/>
-                    </a:solidFill>
-                  </a:tcPr>
-                </a:tc>
-              </a:tr>
-              <a:tr h="197088">
-                <a:tc>
-                  <a:txBody>
-                    <a:bodyPr wrap="square"/>
-                    <a:lstStyle/>
-                    <a:p>
-                      <a:r>
-                        <a:rPr sz="800" b="0" i="0">
-                          <a:solidFill>
-                            <a:srgbClr val="16213A"/>
-                          </a:solidFill>
-                          <a:latin typeface="Arial"/>
-                          <a:ea typeface="Malgun Gothic"/>
-                          <a:cs typeface="Malgun Gothic"/>
-                        </a:rPr>
-                        <a:t>Stereolabs ZED X</a:t>
-                      </a:r>
-                    </a:p>
-                  </a:txBody>
-                  <a:tcPr marL="63500" marR="63500" marT="12700" marB="12700">
-                    <a:solidFill>
-                      <a:srgbClr val="F3F0E8"/>
-                    </a:solidFill>
-                  </a:tcPr>
-                </a:tc>
-                <a:tc>
-                  <a:txBody>
-                    <a:bodyPr wrap="square"/>
-                    <a:lstStyle/>
-                    <a:p>
-                      <a:r>
-                        <a:rPr sz="800" b="0" i="0">
-                          <a:solidFill>
-                            <a:srgbClr val="16213A"/>
-                          </a:solidFill>
-                          <a:latin typeface="Arial"/>
-                          <a:ea typeface="Malgun Gothic"/>
-                          <a:cs typeface="Malgun Gothic"/>
-                        </a:rPr>
-                        <a:t>599달러부터</a:t>
-                      </a:r>
-                    </a:p>
-                  </a:txBody>
-                  <a:tcPr marL="63500" marR="63500" marT="12700" marB="12700">
-                    <a:solidFill>
-                      <a:srgbClr val="F3F0E8"/>
-                    </a:solidFill>
-                  </a:tcPr>
-                </a:tc>
-                <a:tc>
-                  <a:txBody>
-                    <a:bodyPr wrap="square"/>
-                    <a:lstStyle/>
-                    <a:p>
-                      <a:r>
-                        <a:rPr sz="800" b="0" i="0">
-                          <a:solidFill>
-                            <a:srgbClr val="1D4ED8"/>
-                          </a:solidFill>
-                          <a:latin typeface="Arial"/>
-                          <a:ea typeface="Malgun Gothic"/>
-                          <a:cs typeface="Malgun Gothic"/>
-                          <a:hlinkClick r:id="rId10"/>
-                        </a:rPr>
-                        <a:t>Stereolabs</a:t>
-                      </a:r>
-                    </a:p>
-                  </a:txBody>
-                  <a:tcPr marL="63500" marR="63500" marT="12700" marB="12700">
-                    <a:solidFill>
-                      <a:srgbClr val="F3F0E8"/>
-                    </a:solidFill>
-                  </a:tcPr>
-                </a:tc>
-              </a:tr>
-              <a:tr h="197088">
-                <a:tc>
-                  <a:txBody>
-                    <a:bodyPr wrap="square"/>
-                    <a:lstStyle/>
-                    <a:p>
-                      <a:r>
-                        <a:rPr sz="800" b="0" i="0">
-                          <a:solidFill>
-                            <a:srgbClr val="16213A"/>
-                          </a:solidFill>
-                          <a:latin typeface="Arial"/>
-                          <a:ea typeface="Malgun Gothic"/>
-                          <a:cs typeface="Malgun Gothic"/>
-                        </a:rPr>
-                        <a:t>GMSL2 차량용 카메라(IMX490, 120 dB HDR 등)</a:t>
-                      </a:r>
-                    </a:p>
-                  </a:txBody>
-                  <a:tcPr marL="63500" marR="63500" marT="12700" marB="12700">
-                    <a:solidFill>
-                      <a:srgbClr val="FFFDF8"/>
-                    </a:solidFill>
-                  </a:tcPr>
-                </a:tc>
-                <a:tc>
-                  <a:txBody>
-                    <a:bodyPr wrap="square"/>
-                    <a:lstStyle/>
-                    <a:p>
-                      <a:r>
-                        <a:rPr sz="800" b="0" i="0">
-                          <a:solidFill>
-                            <a:srgbClr val="16213A"/>
-                          </a:solidFill>
-                          <a:latin typeface="Arial"/>
-                          <a:ea typeface="Malgun Gothic"/>
-                          <a:cs typeface="Malgun Gothic"/>
-                        </a:rPr>
-                        <a:t>견적</a:t>
-                      </a:r>
-                    </a:p>
-                  </a:txBody>
-                  <a:tcPr marL="63500" marR="63500" marT="12700" marB="12700">
-                    <a:solidFill>
-                      <a:srgbClr val="FFFDF8"/>
-                    </a:solidFill>
-                  </a:tcPr>
-                </a:tc>
-                <a:tc>
-                  <a:txBody>
-                    <a:bodyPr wrap="square"/>
-                    <a:lstStyle/>
-                    <a:p>
-                      <a:r>
-                        <a:rPr sz="800" b="0" i="0">
-                          <a:solidFill>
-                            <a:srgbClr val="1D4ED8"/>
-                          </a:solidFill>
-                          <a:latin typeface="Arial"/>
-                          <a:ea typeface="Malgun Gothic"/>
-                          <a:cs typeface="Malgun Gothic"/>
-                          <a:hlinkClick r:id="rId11"/>
-                        </a:rPr>
-                        <a:t>Leopard Imaging</a:t>
-                      </a:r>
-                    </a:p>
-                  </a:txBody>
-                  <a:tcPr marL="63500" marR="63500" marT="12700" marB="12700">
-                    <a:solidFill>
-                      <a:srgbClr val="FFFDF8"/>
-                    </a:solidFill>
-                  </a:tcPr>
-                </a:tc>
-              </a:tr>
-              <a:tr h="197088">
-                <a:tc>
-                  <a:txBody>
-                    <a:bodyPr wrap="square"/>
-                    <a:lstStyle/>
-                    <a:p>
-                      <a:r>
-                        <a:rPr sz="800" b="0" i="0">
-                          <a:solidFill>
-                            <a:srgbClr val="16213A"/>
-                          </a:solidFill>
-                          <a:latin typeface="Arial"/>
-                          <a:ea typeface="Malgun Gothic"/>
-                          <a:cs typeface="Malgun Gothic"/>
-                        </a:rPr>
-                        <a:t>Jetson AGX Orin 64GB 모듈 / 32GB 모듈</a:t>
-                      </a:r>
-                    </a:p>
-                  </a:txBody>
-                  <a:tcPr marL="63500" marR="63500" marT="12700" marB="12700">
-                    <a:solidFill>
-                      <a:srgbClr val="F3F0E8"/>
-                    </a:solidFill>
-                  </a:tcPr>
-                </a:tc>
-                <a:tc>
-                  <a:txBody>
-                    <a:bodyPr wrap="square"/>
-                    <a:lstStyle/>
-                    <a:p>
-                      <a:r>
-                        <a:rPr sz="800" b="0" i="0">
-                          <a:solidFill>
-                            <a:srgbClr val="16213A"/>
-                          </a:solidFill>
-                          <a:latin typeface="Arial"/>
-                          <a:ea typeface="Malgun Gothic"/>
-                          <a:cs typeface="Malgun Gothic"/>
-                        </a:rPr>
-                        <a:t>2,999 / 1,799달러(인상 전 1,599 / 899)</a:t>
-                      </a:r>
-                    </a:p>
-                  </a:txBody>
-                  <a:tcPr marL="63500" marR="63500" marT="12700" marB="12700">
-                    <a:solidFill>
-                      <a:srgbClr val="F3F0E8"/>
-                    </a:solidFill>
-                  </a:tcPr>
-                </a:tc>
-                <a:tc>
-                  <a:txBody>
-                    <a:bodyPr wrap="square"/>
-                    <a:lstStyle/>
-                    <a:p>
-                      <a:r>
-                        <a:rPr sz="800" b="0" i="0">
-                          <a:solidFill>
-                            <a:srgbClr val="1D4ED8"/>
-                          </a:solidFill>
-                          <a:latin typeface="Arial"/>
-                          <a:ea typeface="Malgun Gothic"/>
-                          <a:cs typeface="Malgun Gothic"/>
-                          <a:hlinkClick r:id="rId12"/>
-                        </a:rPr>
-                        <a:t>CNX Software</a:t>
-                      </a:r>
-                    </a:p>
-                  </a:txBody>
-                  <a:tcPr marL="63500" marR="63500" marT="12700" marB="12700">
-                    <a:solidFill>
-                      <a:srgbClr val="F3F0E8"/>
-                    </a:solidFill>
-                  </a:tcPr>
-                </a:tc>
-              </a:tr>
-              <a:tr h="197088">
-                <a:tc>
-                  <a:txBody>
-                    <a:bodyPr wrap="square"/>
-                    <a:lstStyle/>
-                    <a:p>
-                      <a:r>
-                        <a:rPr sz="800" b="0" i="0">
-                          <a:solidFill>
-                            <a:srgbClr val="16213A"/>
-                          </a:solidFill>
-                          <a:latin typeface="Arial"/>
-                          <a:ea typeface="Malgun Gothic"/>
-                          <a:cs typeface="Malgun Gothic"/>
-                        </a:rPr>
-                        <a:t>Jetson AGX Orin 개발 키트</a:t>
-                      </a:r>
-                    </a:p>
-                  </a:txBody>
-                  <a:tcPr marL="63500" marR="63500" marT="12700" marB="12700">
-                    <a:solidFill>
-                      <a:srgbClr val="FFFDF8"/>
-                    </a:solidFill>
-                  </a:tcPr>
-                </a:tc>
-                <a:tc>
-                  <a:txBody>
-                    <a:bodyPr wrap="square"/>
-                    <a:lstStyle/>
-                    <a:p>
-                      <a:r>
-                        <a:rPr sz="800" b="0" i="0">
-                          <a:solidFill>
-                            <a:srgbClr val="16213A"/>
-                          </a:solidFill>
-                          <a:latin typeface="Arial"/>
-                          <a:ea typeface="Malgun Gothic"/>
-                          <a:cs typeface="Malgun Gothic"/>
-                        </a:rPr>
-                        <a:t>3,499달러(인상 전 1,999)</a:t>
-                      </a:r>
-                    </a:p>
-                  </a:txBody>
-                  <a:tcPr marL="63500" marR="63500" marT="12700" marB="12700">
-                    <a:solidFill>
-                      <a:srgbClr val="FFFDF8"/>
-                    </a:solidFill>
-                  </a:tcPr>
-                </a:tc>
-                <a:tc>
-                  <a:txBody>
-                    <a:bodyPr wrap="square"/>
-                    <a:lstStyle/>
-                    <a:p>
-                      <a:r>
-                        <a:rPr sz="800" b="0" i="0">
-                          <a:solidFill>
-                            <a:srgbClr val="16213A"/>
-                          </a:solidFill>
-                          <a:latin typeface="Arial"/>
-                          <a:ea typeface="Malgun Gothic"/>
-                          <a:cs typeface="Malgun Gothic"/>
-                        </a:rPr>
-                        <a:t>같음</a:t>
-                      </a:r>
-                    </a:p>
-                  </a:txBody>
-                  <a:tcPr marL="63500" marR="63500" marT="12700" marB="12700">
-                    <a:solidFill>
-                      <a:srgbClr val="FFFDF8"/>
-                    </a:solidFill>
-                  </a:tcPr>
-                </a:tc>
-              </a:tr>
-              <a:tr h="197088">
-                <a:tc>
-                  <a:txBody>
-                    <a:bodyPr wrap="square"/>
-                    <a:lstStyle/>
-                    <a:p>
-                      <a:r>
-                        <a:rPr sz="800" b="0" i="0">
-                          <a:solidFill>
-                            <a:srgbClr val="16213A"/>
-                          </a:solidFill>
-                          <a:latin typeface="Arial"/>
-                          <a:ea typeface="Malgun Gothic"/>
-                          <a:cs typeface="Malgun Gothic"/>
-                        </a:rPr>
-                        <a:t>Jetson Orin NX 16GB 모듈</a:t>
-                      </a:r>
-                    </a:p>
-                  </a:txBody>
-                  <a:tcPr marL="63500" marR="63500" marT="12700" marB="12700">
-                    <a:solidFill>
-                      <a:srgbClr val="F3F0E8"/>
-                    </a:solidFill>
-                  </a:tcPr>
-                </a:tc>
-                <a:tc>
-                  <a:txBody>
-                    <a:bodyPr wrap="square"/>
-                    <a:lstStyle/>
-                    <a:p>
-                      <a:r>
-                        <a:rPr sz="800" b="0" i="0">
-                          <a:solidFill>
-                            <a:srgbClr val="16213A"/>
-                          </a:solidFill>
-                          <a:latin typeface="Arial"/>
-                          <a:ea typeface="Malgun Gothic"/>
-                          <a:cs typeface="Malgun Gothic"/>
-                        </a:rPr>
-                        <a:t>999달러(인상 전 599)</a:t>
-                      </a:r>
-                    </a:p>
-                  </a:txBody>
-                  <a:tcPr marL="63500" marR="63500" marT="12700" marB="12700">
-                    <a:solidFill>
-                      <a:srgbClr val="F3F0E8"/>
-                    </a:solidFill>
-                  </a:tcPr>
-                </a:tc>
-                <a:tc>
-                  <a:txBody>
-                    <a:bodyPr wrap="square"/>
-                    <a:lstStyle/>
-                    <a:p>
-                      <a:r>
-                        <a:rPr sz="800" b="0" i="0">
-                          <a:solidFill>
-                            <a:srgbClr val="16213A"/>
-                          </a:solidFill>
-                          <a:latin typeface="Arial"/>
-                          <a:ea typeface="Malgun Gothic"/>
-                          <a:cs typeface="Malgun Gothic"/>
-                        </a:rPr>
-                        <a:t>같음</a:t>
-                      </a:r>
-                    </a:p>
-                  </a:txBody>
-                  <a:tcPr marL="63500" marR="63500" marT="12700" marB="12700">
-                    <a:solidFill>
-                      <a:srgbClr val="F3F0E8"/>
-                    </a:solidFill>
-                  </a:tcPr>
-                </a:tc>
-              </a:tr>
-              <a:tr h="197088">
-                <a:tc>
-                  <a:txBody>
-                    <a:bodyPr wrap="square"/>
-                    <a:lstStyle/>
-                    <a:p>
-                      <a:r>
-                        <a:rPr sz="800" b="0" i="0">
-                          <a:solidFill>
-                            <a:srgbClr val="16213A"/>
-                          </a:solidFill>
-                          <a:latin typeface="Arial"/>
-                          <a:ea typeface="Malgun Gothic"/>
-                          <a:cs typeface="Malgun Gothic"/>
-                        </a:rPr>
-                        <a:t>Jetson T4000 / T5000(Thor) 모듈</a:t>
-                      </a:r>
-                    </a:p>
-                  </a:txBody>
-                  <a:tcPr marL="63500" marR="63500" marT="12700" marB="12700">
-                    <a:solidFill>
-                      <a:srgbClr val="FFFDF8"/>
-                    </a:solidFill>
-                  </a:tcPr>
-                </a:tc>
-                <a:tc>
-                  <a:txBody>
-                    <a:bodyPr wrap="square"/>
-                    <a:lstStyle/>
-                    <a:p>
-                      <a:r>
-                        <a:rPr sz="800" b="0" i="0">
-                          <a:solidFill>
-                            <a:srgbClr val="16213A"/>
-                          </a:solidFill>
-                          <a:latin typeface="Arial"/>
-                          <a:ea typeface="Malgun Gothic"/>
-                          <a:cs typeface="Malgun Gothic"/>
-                        </a:rPr>
-                        <a:t>2,999 / 4,999달러</a:t>
-                      </a:r>
-                    </a:p>
-                  </a:txBody>
-                  <a:tcPr marL="63500" marR="63500" marT="12700" marB="12700">
-                    <a:solidFill>
-                      <a:srgbClr val="FFFDF8"/>
-                    </a:solidFill>
-                  </a:tcPr>
-                </a:tc>
-                <a:tc>
-                  <a:txBody>
-                    <a:bodyPr wrap="square"/>
-                    <a:lstStyle/>
-                    <a:p>
-                      <a:r>
-                        <a:rPr sz="800" b="0" i="0">
-                          <a:solidFill>
-                            <a:srgbClr val="16213A"/>
-                          </a:solidFill>
-                          <a:latin typeface="Arial"/>
-                          <a:ea typeface="Malgun Gothic"/>
-                          <a:cs typeface="Malgun Gothic"/>
-                        </a:rPr>
-                        <a:t>같음</a:t>
-                      </a:r>
-                    </a:p>
-                  </a:txBody>
-                  <a:tcPr marL="63500" marR="63500" marT="12700" marB="12700">
-                    <a:solidFill>
-                      <a:srgbClr val="FFFDF8"/>
-                    </a:solidFill>
-                  </a:tcPr>
-                </a:tc>
-              </a:tr>
-            </a:tbl>
-          </a:graphicData>
-        </a:graphic>
-      </p:graphicFrame>
-      <p:sp>
-        <p:nvSpPr>
-          <p:cNvPr id="7" name="TextBox 6"/>
-          <p:cNvSpPr txBox="1"/>
-          <p:nvPr/>
-        </p:nvSpPr>
-        <p:spPr>
-          <a:xfrm>
-            <a:off x="609600" y="4601567"/>
-            <a:ext cx="10972800" cy="216495"/>
-          </a:xfrm>
-          <a:prstGeom prst="rect">
-            <a:avLst/>
-          </a:prstGeom>
-          <a:noFill/>
-        </p:spPr>
-        <p:txBody>
-          <a:bodyPr wrap="square" lIns="0" rIns="0" tIns="0" bIns="0" anchor="t">
-            <a:spAutoFit/>
-            <a:normAutofit/>
-          </a:bodyPr>
-          <a:lstStyle/>
-          <a:p>
-            <a:r>
-              <a:rPr sz="1050" b="1" i="0">
-                <a:solidFill>
-                  <a:srgbClr val="16213A"/>
-                </a:solidFill>
-                <a:latin typeface="Arial"/>
-                <a:ea typeface="Malgun Gothic"/>
-                <a:cs typeface="Malgun Gothic"/>
-              </a:rPr>
-              <a:t>배치별 센서 + 연산 예산(대략).</a:t>
-            </a:r>
-            <a:r>
-              <a:rPr sz="1050" b="0" i="0">
-                <a:solidFill>
-                  <a:srgbClr val="16213A"/>
-                </a:solidFill>
-                <a:latin typeface="Arial"/>
-                <a:ea typeface="Malgun Gothic"/>
-                <a:cs typeface="Malgun Gothic"/>
-              </a:rPr>
-              <a:t> 카메라 한 대를 200–600달러로 보면 다음과 같다.</a:t>
-            </a:r>
-          </a:p>
-        </p:txBody>
-      </p:sp>
-      <p:graphicFrame>
-        <p:nvGraphicFramePr>
-          <p:cNvPr id="8" name="Table 7"/>
-          <p:cNvGraphicFramePr>
-            <a:graphicFrameLocks noGrp="1"/>
-          </p:cNvGraphicFramePr>
-          <p:nvPr/>
-        </p:nvGraphicFramePr>
-        <p:xfrm>
-          <a:off x="609600" y="4906962"/>
-          <a:ext cx="10966450" cy="985440"/>
-        </p:xfrm>
-        <a:graphic>
-          <a:graphicData uri="http://schemas.openxmlformats.org/drawingml/2006/table">
-            <a:tbl>
-              <a:tblPr firstRow="1" bandRow="1">
-                <a:tableStyleId>{5C22544A-7EE6-4342-B048-85BDC9FD1C3A}</a:tableStyleId>
-              </a:tblPr>
-              <a:tblGrid>
-                <a:gridCol w="3432373"/>
-                <a:gridCol w="1907977"/>
-                <a:gridCol w="3606800"/>
-                <a:gridCol w="2019300"/>
-              </a:tblGrid>
-              <a:tr h="197088">
-                <a:tc>
-                  <a:txBody>
-                    <a:bodyPr wrap="square"/>
-                    <a:lstStyle/>
-                    <a:p>
-                      <a:r>
-                        <a:rPr sz="800" b="1" i="0">
-                          <a:solidFill>
-                            <a:srgbClr val="F4F1EA"/>
-                          </a:solidFill>
-                          <a:latin typeface="Arial"/>
-                          <a:ea typeface="Malgun Gothic"/>
-                          <a:cs typeface="Malgun Gothic"/>
-                        </a:rPr>
-                        <a:t>배치</a:t>
-                      </a:r>
-                    </a:p>
-                  </a:txBody>
-                  <a:tcPr marL="63500" marR="63500" marT="12700" marB="12700">
-                    <a:solidFill>
-                      <a:srgbClr val="16213A"/>
-                    </a:solidFill>
-                  </a:tcPr>
-                </a:tc>
-                <a:tc>
-                  <a:txBody>
-                    <a:bodyPr wrap="square"/>
-                    <a:lstStyle/>
-                    <a:p>
-                      <a:r>
-                        <a:rPr sz="800" b="1" i="0">
-                          <a:solidFill>
-                            <a:srgbClr val="F4F1EA"/>
-                          </a:solidFill>
-                          <a:latin typeface="Arial"/>
-                          <a:ea typeface="Malgun Gothic"/>
-                          <a:cs typeface="Malgun Gothic"/>
-                        </a:rPr>
-                        <a:t>센서</a:t>
-                      </a:r>
-                    </a:p>
-                  </a:txBody>
-                  <a:tcPr marL="63500" marR="63500" marT="12700" marB="12700">
-                    <a:solidFill>
-                      <a:srgbClr val="16213A"/>
-                    </a:solidFill>
-                  </a:tcPr>
-                </a:tc>
-                <a:tc>
-                  <a:txBody>
-                    <a:bodyPr wrap="square"/>
-                    <a:lstStyle/>
-                    <a:p>
-                      <a:r>
-                        <a:rPr sz="800" b="1" i="0">
-                          <a:solidFill>
-                            <a:srgbClr val="F4F1EA"/>
-                          </a:solidFill>
-                          <a:latin typeface="Arial"/>
-                          <a:ea typeface="Malgun Gothic"/>
-                          <a:cs typeface="Malgun Gothic"/>
-                        </a:rPr>
-                        <a:t>연산</a:t>
-                      </a:r>
-                    </a:p>
-                  </a:txBody>
-                  <a:tcPr marL="63500" marR="63500" marT="12700" marB="12700">
-                    <a:solidFill>
-                      <a:srgbClr val="16213A"/>
-                    </a:solidFill>
-                  </a:tcPr>
-                </a:tc>
-                <a:tc>
-                  <a:txBody>
-                    <a:bodyPr wrap="square"/>
-                    <a:lstStyle/>
-                    <a:p>
-                      <a:r>
-                        <a:rPr sz="800" b="1" i="0">
-                          <a:solidFill>
-                            <a:srgbClr val="F4F1EA"/>
-                          </a:solidFill>
-                          <a:latin typeface="Arial"/>
-                          <a:ea typeface="Malgun Gothic"/>
-                          <a:cs typeface="Malgun Gothic"/>
-                        </a:rPr>
-                        <a:t>합계</a:t>
-                      </a:r>
-                    </a:p>
-                  </a:txBody>
-                  <a:tcPr marL="63500" marR="63500" marT="12700" marB="12700">
-                    <a:solidFill>
-                      <a:srgbClr val="16213A"/>
-                    </a:solidFill>
-                  </a:tcPr>
-                </a:tc>
-              </a:tr>
-              <a:tr h="197088">
-                <a:tc>
-                  <a:txBody>
-                    <a:bodyPr wrap="square"/>
-                    <a:lstStyle/>
-                    <a:p>
-                      <a:r>
-                        <a:rPr sz="800" b="0" i="0">
-                          <a:solidFill>
-                            <a:srgbClr val="16213A"/>
-                          </a:solidFill>
-                          <a:latin typeface="Arial"/>
-                          <a:ea typeface="Malgun Gothic"/>
-                          <a:cs typeface="Malgun Gothic"/>
-                        </a:rPr>
-                        <a:t>A. 전면 Mid-360 + 스테레오 1 + 카메라 3</a:t>
-                      </a:r>
-                    </a:p>
-                  </a:txBody>
-                  <a:tcPr marL="63500" marR="63500" marT="12700" marB="12700">
-                    <a:solidFill>
-                      <a:srgbClr val="FFFDF8"/>
-                    </a:solidFill>
-                  </a:tcPr>
-                </a:tc>
-                <a:tc>
-                  <a:txBody>
-                    <a:bodyPr wrap="square"/>
-                    <a:lstStyle/>
-                    <a:p>
-                      <a:r>
-                        <a:rPr sz="800" b="0" i="0">
-                          <a:solidFill>
-                            <a:srgbClr val="16213A"/>
-                          </a:solidFill>
-                          <a:latin typeface="Arial"/>
-                          <a:ea typeface="Malgun Gothic"/>
-                          <a:cs typeface="Malgun Gothic"/>
-                        </a:rPr>
-                        <a:t>약 1,600–3,700달러</a:t>
-                      </a:r>
-                    </a:p>
-                  </a:txBody>
-                  <a:tcPr marL="63500" marR="63500" marT="12700" marB="12700">
-                    <a:solidFill>
-                      <a:srgbClr val="FFFDF8"/>
-                    </a:solidFill>
-                  </a:tcPr>
-                </a:tc>
-                <a:tc>
-                  <a:txBody>
-                    <a:bodyPr wrap="square"/>
-                    <a:lstStyle/>
-                    <a:p>
-                      <a:r>
-                        <a:rPr sz="800" b="0" i="0">
-                          <a:solidFill>
-                            <a:srgbClr val="16213A"/>
-                          </a:solidFill>
-                          <a:latin typeface="Arial"/>
-                          <a:ea typeface="Malgun Gothic"/>
-                          <a:cs typeface="Malgun Gothic"/>
-                        </a:rPr>
-                        <a:t>AGX Orin 32GB 1,799달러</a:t>
-                      </a:r>
-                    </a:p>
-                  </a:txBody>
-                  <a:tcPr marL="63500" marR="63500" marT="12700" marB="12700">
-                    <a:solidFill>
-                      <a:srgbClr val="FFFDF8"/>
-                    </a:solidFill>
-                  </a:tcPr>
-                </a:tc>
-                <a:tc>
-                  <a:txBody>
-                    <a:bodyPr wrap="square"/>
-                    <a:lstStyle/>
-                    <a:p>
-                      <a:r>
-                        <a:rPr sz="800" b="0" i="0">
-                          <a:solidFill>
-                            <a:srgbClr val="16213A"/>
-                          </a:solidFill>
-                          <a:latin typeface="Arial"/>
-                          <a:ea typeface="Malgun Gothic"/>
-                          <a:cs typeface="Malgun Gothic"/>
-                        </a:rPr>
-                        <a:t>약 3,400–5,500달러</a:t>
-                      </a:r>
-                    </a:p>
-                  </a:txBody>
-                  <a:tcPr marL="63500" marR="63500" marT="12700" marB="12700">
-                    <a:solidFill>
-                      <a:srgbClr val="FFFDF8"/>
-                    </a:solidFill>
-                  </a:tcPr>
-                </a:tc>
-              </a:tr>
-              <a:tr h="197088">
-                <a:tc>
-                  <a:txBody>
-                    <a:bodyPr wrap="square"/>
-                    <a:lstStyle/>
-                    <a:p>
-                      <a:r>
-                        <a:rPr sz="800" b="0" i="0">
-                          <a:solidFill>
-                            <a:srgbClr val="16213A"/>
-                          </a:solidFill>
-                          <a:latin typeface="Arial"/>
-                          <a:ea typeface="Malgun Gothic"/>
-                          <a:cs typeface="Malgun Gothic"/>
-                        </a:rPr>
-                        <a:t>A + D. 위 + 후면 L2</a:t>
-                      </a:r>
-                    </a:p>
-                  </a:txBody>
-                  <a:tcPr marL="63500" marR="63500" marT="12700" marB="12700">
-                    <a:solidFill>
-                      <a:srgbClr val="F3F0E8"/>
-                    </a:solidFill>
-                  </a:tcPr>
-                </a:tc>
-                <a:tc>
-                  <a:txBody>
-                    <a:bodyPr wrap="square"/>
-                    <a:lstStyle/>
-                    <a:p>
-                      <a:r>
-                        <a:rPr sz="800" b="0" i="0">
-                          <a:solidFill>
-                            <a:srgbClr val="16213A"/>
-                          </a:solidFill>
-                          <a:latin typeface="Arial"/>
-                          <a:ea typeface="Malgun Gothic"/>
-                          <a:cs typeface="Malgun Gothic"/>
-                        </a:rPr>
-                        <a:t>약 2,000–4,100달러</a:t>
-                      </a:r>
-                    </a:p>
-                  </a:txBody>
-                  <a:tcPr marL="63500" marR="63500" marT="12700" marB="12700">
-                    <a:solidFill>
-                      <a:srgbClr val="F3F0E8"/>
-                    </a:solidFill>
-                  </a:tcPr>
-                </a:tc>
-                <a:tc>
-                  <a:txBody>
-                    <a:bodyPr wrap="square"/>
-                    <a:lstStyle/>
-                    <a:p>
-                      <a:r>
-                        <a:rPr sz="800" b="0" i="0">
-                          <a:solidFill>
-                            <a:srgbClr val="16213A"/>
-                          </a:solidFill>
-                          <a:latin typeface="Arial"/>
-                          <a:ea typeface="Malgun Gothic"/>
-                          <a:cs typeface="Malgun Gothic"/>
-                        </a:rPr>
-                        <a:t>같음</a:t>
-                      </a:r>
-                    </a:p>
-                  </a:txBody>
-                  <a:tcPr marL="63500" marR="63500" marT="12700" marB="12700">
-                    <a:solidFill>
-                      <a:srgbClr val="F3F0E8"/>
-                    </a:solidFill>
-                  </a:tcPr>
-                </a:tc>
-                <a:tc>
-                  <a:txBody>
-                    <a:bodyPr wrap="square"/>
-                    <a:lstStyle/>
-                    <a:p>
-                      <a:r>
-                        <a:rPr sz="800" b="0" i="0">
-                          <a:solidFill>
-                            <a:srgbClr val="16213A"/>
-                          </a:solidFill>
-                          <a:latin typeface="Arial"/>
-                          <a:ea typeface="Malgun Gothic"/>
-                          <a:cs typeface="Malgun Gothic"/>
-                        </a:rPr>
-                        <a:t>약 3,800–5,900달러</a:t>
-                      </a:r>
-                    </a:p>
-                  </a:txBody>
-                  <a:tcPr marL="63500" marR="63500" marT="12700" marB="12700">
-                    <a:solidFill>
-                      <a:srgbClr val="F3F0E8"/>
-                    </a:solidFill>
-                  </a:tcPr>
-                </a:tc>
-              </a:tr>
-              <a:tr h="197088">
-                <a:tc>
-                  <a:txBody>
-                    <a:bodyPr wrap="square"/>
-                    <a:lstStyle/>
-                    <a:p>
-                      <a:r>
-                        <a:rPr sz="800" b="0" i="0">
-                          <a:solidFill>
-                            <a:srgbClr val="16213A"/>
-                          </a:solidFill>
-                          <a:latin typeface="Arial"/>
-                          <a:ea typeface="Malgun Gothic"/>
-                          <a:cs typeface="Malgun Gothic"/>
-                        </a:rPr>
-                        <a:t>B. Ouster 32채널 + 스테레오 + 카메라 3</a:t>
-                      </a:r>
-                    </a:p>
-                  </a:txBody>
-                  <a:tcPr marL="63500" marR="63500" marT="12700" marB="12700">
-                    <a:solidFill>
-                      <a:srgbClr val="FFFDF8"/>
-                    </a:solidFill>
-                  </a:tcPr>
-                </a:tc>
-                <a:tc>
-                  <a:txBody>
-                    <a:bodyPr wrap="square"/>
-                    <a:lstStyle/>
-                    <a:p>
-                      <a:r>
-                        <a:rPr sz="800" b="0" i="0">
-                          <a:solidFill>
-                            <a:srgbClr val="16213A"/>
-                          </a:solidFill>
-                          <a:latin typeface="Arial"/>
-                          <a:ea typeface="Malgun Gothic"/>
-                          <a:cs typeface="Malgun Gothic"/>
-                        </a:rPr>
-                        <a:t>약 7,100–8,300달러</a:t>
-                      </a:r>
-                    </a:p>
-                  </a:txBody>
-                  <a:tcPr marL="63500" marR="63500" marT="12700" marB="12700">
-                    <a:solidFill>
-                      <a:srgbClr val="FFFDF8"/>
-                    </a:solidFill>
-                  </a:tcPr>
-                </a:tc>
-                <a:tc>
-                  <a:txBody>
-                    <a:bodyPr wrap="square"/>
-                    <a:lstStyle/>
-                    <a:p>
-                      <a:r>
-                        <a:rPr sz="800" b="0" i="0">
-                          <a:solidFill>
-                            <a:srgbClr val="16213A"/>
-                          </a:solidFill>
-                          <a:latin typeface="Arial"/>
-                          <a:ea typeface="Malgun Gothic"/>
-                          <a:cs typeface="Malgun Gothic"/>
-                        </a:rPr>
-                        <a:t>같음</a:t>
-                      </a:r>
-                    </a:p>
-                  </a:txBody>
-                  <a:tcPr marL="63500" marR="63500" marT="12700" marB="12700">
-                    <a:solidFill>
-                      <a:srgbClr val="FFFDF8"/>
-                    </a:solidFill>
-                  </a:tcPr>
-                </a:tc>
-                <a:tc>
-                  <a:txBody>
-                    <a:bodyPr wrap="square"/>
-                    <a:lstStyle/>
-                    <a:p>
-                      <a:r>
-                        <a:rPr sz="800" b="0" i="0">
-                          <a:solidFill>
-                            <a:srgbClr val="16213A"/>
-                          </a:solidFill>
-                          <a:latin typeface="Arial"/>
-                          <a:ea typeface="Malgun Gothic"/>
-                          <a:cs typeface="Malgun Gothic"/>
-                        </a:rPr>
-                        <a:t>약 8,900–10,100달러</a:t>
-                      </a:r>
-                    </a:p>
-                  </a:txBody>
-                  <a:tcPr marL="63500" marR="63500" marT="12700" marB="12700">
-                    <a:solidFill>
-                      <a:srgbClr val="FFFDF8"/>
-                    </a:solidFill>
-                  </a:tcPr>
-                </a:tc>
-              </a:tr>
-              <a:tr h="197088">
-                <a:tc>
-                  <a:txBody>
-                    <a:bodyPr wrap="square"/>
-                    <a:lstStyle/>
-                    <a:p>
-                      <a:r>
-                        <a:rPr sz="800" b="0" i="0">
-                          <a:solidFill>
-                            <a:srgbClr val="16213A"/>
-                          </a:solidFill>
-                          <a:latin typeface="Arial"/>
-                          <a:ea typeface="Malgun Gothic"/>
-                          <a:cs typeface="Malgun Gothic"/>
-                        </a:rPr>
-                        <a:t>C. 카메라 10대 이상 + 초음파·레이더</a:t>
-                      </a:r>
-                    </a:p>
-                  </a:txBody>
-                  <a:tcPr marL="63500" marR="63500" marT="12700" marB="12700">
-                    <a:solidFill>
-                      <a:srgbClr val="F3F0E8"/>
-                    </a:solidFill>
-                  </a:tcPr>
-                </a:tc>
-                <a:tc>
-                  <a:txBody>
-                    <a:bodyPr wrap="square"/>
-                    <a:lstStyle/>
-                    <a:p>
-                      <a:r>
-                        <a:rPr sz="800" b="0" i="0">
-                          <a:solidFill>
-                            <a:srgbClr val="16213A"/>
-                          </a:solidFill>
-                          <a:latin typeface="Arial"/>
-                          <a:ea typeface="Malgun Gothic"/>
-                          <a:cs typeface="Malgun Gothic"/>
-                        </a:rPr>
-                        <a:t>약 2,000–6,000달러</a:t>
-                      </a:r>
-                    </a:p>
-                  </a:txBody>
-                  <a:tcPr marL="63500" marR="63500" marT="12700" marB="12700">
-                    <a:solidFill>
-                      <a:srgbClr val="F3F0E8"/>
-                    </a:solidFill>
-                  </a:tcPr>
-                </a:tc>
-                <a:tc>
-                  <a:txBody>
-                    <a:bodyPr wrap="square"/>
-                    <a:lstStyle/>
-                    <a:p>
-                      <a:r>
-                        <a:rPr sz="800" b="0" i="0">
-                          <a:solidFill>
-                            <a:srgbClr val="16213A"/>
-                          </a:solidFill>
-                          <a:latin typeface="Arial"/>
-                          <a:ea typeface="Malgun Gothic"/>
-                          <a:cs typeface="Malgun Gothic"/>
-                        </a:rPr>
-                        <a:t>AGX Orin 64GB 2,999달러(학습 모델 부하)</a:t>
-                      </a:r>
-                    </a:p>
-                  </a:txBody>
-                  <a:tcPr marL="63500" marR="63500" marT="12700" marB="12700">
-                    <a:solidFill>
-                      <a:srgbClr val="F3F0E8"/>
-                    </a:solidFill>
-                  </a:tcPr>
-                </a:tc>
-                <a:tc>
-                  <a:txBody>
-                    <a:bodyPr wrap="square"/>
-                    <a:lstStyle/>
-                    <a:p>
-                      <a:r>
-                        <a:rPr sz="800" b="0" i="0">
-                          <a:solidFill>
-                            <a:srgbClr val="16213A"/>
-                          </a:solidFill>
-                          <a:latin typeface="Arial"/>
-                          <a:ea typeface="Malgun Gothic"/>
-                          <a:cs typeface="Malgun Gothic"/>
-                        </a:rPr>
-                        <a:t>약 5,000–9,000달러</a:t>
-                      </a:r>
-                    </a:p>
-                  </a:txBody>
-                  <a:tcPr marL="63500" marR="63500" marT="12700" marB="12700">
-                    <a:solidFill>
-                      <a:srgbClr val="F3F0E8"/>
-                    </a:solidFill>
-                  </a:tcPr>
-                </a:tc>
-              </a:tr>
-            </a:tbl>
-          </a:graphicData>
-        </a:graphic>
-      </p:graphicFrame>
+              <a:t>그림 — CODEI (Fig. 1): 도심 자율주행차를 부품 목록(차체, 센서, 검출기, 계획기, 연산 장치)에서 골라 설계하는 문제의 개념도. 출처: arXiv:2503.10296</a:t>
+            </a:r>
+          </a:p>
+        </p:txBody>
+      </p:sp>
     </p:spTree>
   </p:cSld>
   <p:clrMapOvr>
@@ -12714,7 +13395,7 @@
     <p:bg>
       <p:bgPr>
         <a:solidFill>
-          <a:srgbClr val="F7F5F0"/>
+          <a:srgbClr val="16213A"/>
         </a:solidFill>
         <a:effectLst/>
       </p:bgPr>
@@ -12752,13 +13433,13 @@
             <a:r>
               <a:rPr sz="850" b="1" i="0">
                 <a:solidFill>
-                  <a:srgbClr val="C2410C"/>
+                  <a:srgbClr val="F59E5B"/>
                 </a:solidFill>
                 <a:latin typeface="Consolas"/>
                 <a:ea typeface="Malgun Gothic"/>
                 <a:cs typeface="Malgun Gothic"/>
               </a:rPr>
-              <a:t>센서 배치 · 가격·연산</a:t>
+              <a:t>센서 배치 · 탭</a:t>
             </a:r>
           </a:p>
         </p:txBody>
@@ -12771,7 +13452,7 @@
         </p:nvSpPr>
         <p:spPr>
           <a:xfrm>
-            <a:off x="609600" y="558800"/>
+            <a:off x="609600" y="609600"/>
             <a:ext cx="10972800" cy="381000"/>
           </a:xfrm>
           <a:prstGeom prst="rect">
@@ -12787,26 +13468,15 @@
           <a:lstStyle/>
           <a:p>
             <a:r>
-              <a:rPr sz="2000" b="1" i="0">
-                <a:solidFill>
-                  <a:srgbClr val="16213A"/>
+              <a:rPr sz="2650" b="1" i="0">
+                <a:solidFill>
+                  <a:srgbClr val="F4F1EA"/>
                 </a:solidFill>
                 <a:latin typeface="Arial"/>
                 <a:ea typeface="Malgun Gothic"/>
                 <a:cs typeface="Malgun Gothic"/>
               </a:rPr>
-              <a:t>H.3 예상 가격 (2026-09 기준)</a:t>
-            </a:r>
-            <a:r>
-              <a:rPr sz="1050" b="0" i="0">
-                <a:solidFill>
-                  <a:srgbClr val="5A6478"/>
-                </a:solidFill>
-                <a:latin typeface="Arial"/>
-                <a:ea typeface="Malgun Gothic"/>
-                <a:cs typeface="Malgun Gothic"/>
-              </a:rPr>
-              <a:t>  2/2</a:t>
+              <a:t>가격·연산</a:t>
             </a:r>
           </a:p>
         </p:txBody>
@@ -12837,13 +13507,13 @@
             <a:r>
               <a:rPr sz="650" b="0" i="0">
                 <a:solidFill>
-                  <a:srgbClr val="5A6478"/>
+                  <a:srgbClr val="9AA6BC"/>
                 </a:solidFill>
                 <a:latin typeface="Arial"/>
                 <a:ea typeface="Malgun Gothic"/>
                 <a:cs typeface="Malgun Gothic"/>
               </a:rPr>
-              <a:t>travplan 리서치 · 센서 배치 (docs/research-sensors.md)    9 / 12</a:t>
+              <a:t>travplan 리서치 · 센서 배치 (docs/research-sensors.md)    9 / 14</a:t>
             </a:r>
           </a:p>
         </p:txBody>
@@ -12857,7 +13527,7 @@
         <p:spPr>
           <a:xfrm>
             <a:off x="609600" y="1244600"/>
-            <a:ext cx="10972800" cy="216495"/>
+            <a:ext cx="5283200" cy="5080000"/>
           </a:xfrm>
           <a:prstGeom prst="rect">
             <a:avLst/>
@@ -12871,16 +13541,63 @@
           </a:bodyPr>
           <a:lstStyle/>
           <a:p>
-            <a:r>
-              <a:rPr sz="1050" b="0" i="0">
-                <a:solidFill>
-                  <a:srgbClr val="16213A"/>
+            <a:pPr>
+              <a:spcAft>
+                <a:spcPts val="400"/>
+              </a:spcAft>
+            </a:pPr>
+            <a:r>
+              <a:rPr sz="1000" b="1" i="0">
+                <a:solidFill>
+                  <a:srgbClr val="F59E5B"/>
                 </a:solidFill>
                 <a:latin typeface="Arial"/>
                 <a:ea typeface="Malgun Gothic"/>
                 <a:cs typeface="Malgun Gothic"/>
               </a:rPr>
-              <a:t>합계에는 배선, 캐리어 보드, 보정 장비, 방수 하우징이 빠져 있다.</a:t>
+              <a:t>H.3 예상 가격 (2026-09 기준)</a:t>
+            </a:r>
+          </a:p>
+        </p:txBody>
+      </p:sp>
+      <p:sp>
+        <p:nvSpPr>
+          <p:cNvPr id="6" name="TextBox 5"/>
+          <p:cNvSpPr txBox="1"/>
+          <p:nvPr/>
+        </p:nvSpPr>
+        <p:spPr>
+          <a:xfrm>
+            <a:off x="6299200" y="1244600"/>
+            <a:ext cx="5283200" cy="5080000"/>
+          </a:xfrm>
+          <a:prstGeom prst="rect">
+            <a:avLst/>
+          </a:prstGeom>
+          <a:noFill/>
+        </p:spPr>
+        <p:txBody>
+          <a:bodyPr wrap="square" lIns="0" rIns="0" tIns="0" bIns="0" anchor="t">
+            <a:spAutoFit/>
+            <a:normAutofit/>
+          </a:bodyPr>
+          <a:lstStyle/>
+          <a:p>
+            <a:pPr>
+              <a:spcAft>
+                <a:spcPts val="400"/>
+              </a:spcAft>
+            </a:pPr>
+            <a:r>
+              <a:rPr sz="1000" b="1" i="0">
+                <a:solidFill>
+                  <a:srgbClr val="F59E5B"/>
+                </a:solidFill>
+                <a:latin typeface="Arial"/>
+                <a:ea typeface="Malgun Gothic"/>
+                <a:cs typeface="Malgun Gothic"/>
+              </a:rPr>
+              <a:t>H.4 필요한 연산 성능</a:t>
             </a:r>
           </a:p>
         </p:txBody>

</xml_diff>